<commit_message>
Restore original Spanish document and deck designs in the English edition
Preserve original artwork, page geometry, colours and typography; translate text in place. Restore contact artwork and FARMAGEND branding, and refresh document viewer URLs.
</commit_message>
<xml_diff>
--- a/en/assets/Perfil_Deportivo_Ramon_Curbalan_Vega.pptx
+++ b/en/assets/Perfil_Deportivo_Ramon_Curbalan_Vega.pptx
@@ -2,18 +2,18 @@
 <file path=ppt/presentation.xml><?xml version="1.0" encoding="utf-8"?>
 <p:presentation xmlns:p="http://schemas.openxmlformats.org/presentationml/2006/main">
   <p:sldMasterIdLst>
-    <p:sldMasterId xmlns:r="http://schemas.openxmlformats.org/officeDocument/2006/relationships" id="2147483648" r:id="R6af016d76a4741ec"/>
+    <p:sldMasterId xmlns:r="http://schemas.openxmlformats.org/officeDocument/2006/relationships" id="2147483648" r:id="Rf5cdf5c184c54ed9"/>
   </p:sldMasterIdLst>
   <p:notesMasterIdLst>
-    <p:notesMasterId xmlns:r="http://schemas.openxmlformats.org/officeDocument/2006/relationships" r:id="Rd2b6399c5b79416b"/>
+    <p:notesMasterId xmlns:r="http://schemas.openxmlformats.org/officeDocument/2006/relationships" r:id="R82d1b38751fb45ac"/>
   </p:notesMasterIdLst>
   <p:sldIdLst>
-    <p:sldId xmlns:r="http://schemas.openxmlformats.org/officeDocument/2006/relationships" id="256" r:id="R3370fed994314983"/>
-    <p:sldId xmlns:r="http://schemas.openxmlformats.org/officeDocument/2006/relationships" id="257" r:id="R1a0c677e31d8448a"/>
-    <p:sldId xmlns:r="http://schemas.openxmlformats.org/officeDocument/2006/relationships" id="258" r:id="Re23fd22363a7487a"/>
-    <p:sldId xmlns:r="http://schemas.openxmlformats.org/officeDocument/2006/relationships" id="259" r:id="Red4f88e1444a4cbf"/>
-    <p:sldId xmlns:r="http://schemas.openxmlformats.org/officeDocument/2006/relationships" id="260" r:id="R2335ce90ba4c4a88"/>
-    <p:sldId xmlns:r="http://schemas.openxmlformats.org/officeDocument/2006/relationships" id="261" r:id="Rf84f670c974f4ed6"/>
+    <p:sldId xmlns:r="http://schemas.openxmlformats.org/officeDocument/2006/relationships" id="256" r:id="Redf14322b6954e6e"/>
+    <p:sldId xmlns:r="http://schemas.openxmlformats.org/officeDocument/2006/relationships" id="257" r:id="R96fb3229008140ca"/>
+    <p:sldId xmlns:r="http://schemas.openxmlformats.org/officeDocument/2006/relationships" id="258" r:id="Rf0a728c1977c4aef"/>
+    <p:sldId xmlns:r="http://schemas.openxmlformats.org/officeDocument/2006/relationships" id="259" r:id="R5e3e1b22eeb04f88"/>
+    <p:sldId xmlns:r="http://schemas.openxmlformats.org/officeDocument/2006/relationships" id="260" r:id="R1d97e2f1172b48ed"/>
+    <p:sldId xmlns:r="http://schemas.openxmlformats.org/officeDocument/2006/relationships" id="261" r:id="Rf4fecf87d7b44d46"/>
   </p:sldIdLst>
   <p:sldSz cx="12192000" cy="6858000"/>
   <p:notesSz cx="6858000" cy="9144000"/>
@@ -447,7 +447,7 @@
           <a:lstStyle xmlns:a="http://schemas.openxmlformats.org/drawingml/2006/main"/>
           <a:p xmlns:a="http://schemas.openxmlformats.org/drawingml/2006/main">
             <a:r>
-              <a:t>English edition of the supplied professional profile. The original Spanish file remains unchanged.</a:t>
+              <a:t>Fotografía extraída del PDF original aportado por el usuario. Paleta verde inspirada en la referencia «Explorar Deporte». Fuente de contenido: Carta_presentacion_deportiva_profesional_v2.pdf.</a:t>
             </a:r>
           </a:p>
         </p:txBody>
@@ -517,7 +517,7 @@
           <a:lstStyle xmlns:a="http://schemas.openxmlformats.org/drawingml/2006/main"/>
           <a:p xmlns:a="http://schemas.openxmlformats.org/drawingml/2006/main">
             <a:r>
-              <a:t>Source: supplied Spanish professional portfolio. English translation preserves the stated experience, skills and objectives.</a:t>
+              <a:t>Fuente: Carta_presentacion_deportiva_profesional_v2.pdf, aportado por el usuario. Se conserva el alcance de la experiencia y formación descritas, sin añadir titulaciones ni resultados cuantificados.</a:t>
             </a:r>
           </a:p>
         </p:txBody>
@@ -587,7 +587,7 @@
           <a:lstStyle xmlns:a="http://schemas.openxmlformats.org/drawingml/2006/main"/>
           <a:p xmlns:a="http://schemas.openxmlformats.org/drawingml/2006/main">
             <a:r>
-              <a:t>Source: supplied Spanish professional portfolio. English translation preserves the stated experience, skills and objectives.</a:t>
+              <a:t>Fuente: Carta_presentacion_deportiva_profesional_v2.pdf, aportado por el usuario. Se conserva el alcance de la experiencia y formación descritas, sin añadir titulaciones ni resultados cuantificados.</a:t>
             </a:r>
           </a:p>
         </p:txBody>
@@ -657,7 +657,7 @@
           <a:lstStyle xmlns:a="http://schemas.openxmlformats.org/drawingml/2006/main"/>
           <a:p xmlns:a="http://schemas.openxmlformats.org/drawingml/2006/main">
             <a:r>
-              <a:t>Source: supplied Spanish professional portfolio. English translation preserves the stated experience, skills and objectives.</a:t>
+              <a:t>Fuente: Carta_presentacion_deportiva_profesional_v2.pdf, aportado por el usuario. Se conserva el alcance de la experiencia y formación descritas, sin añadir titulaciones ni resultados cuantificados.</a:t>
             </a:r>
           </a:p>
         </p:txBody>
@@ -727,7 +727,7 @@
           <a:lstStyle xmlns:a="http://schemas.openxmlformats.org/drawingml/2006/main"/>
           <a:p xmlns:a="http://schemas.openxmlformats.org/drawingml/2006/main">
             <a:r>
-              <a:t>Source: supplied Spanish professional portfolio. English translation preserves the stated experience, skills and objectives.</a:t>
+              <a:t>Fuente: Carta_presentacion_deportiva_profesional_v2.pdf, aportado por el usuario. Se conserva el alcance de la experiencia y formación descritas, sin añadir titulaciones ni resultados cuantificados.</a:t>
             </a:r>
           </a:p>
         </p:txBody>
@@ -797,7 +797,7 @@
           <a:lstStyle xmlns:a="http://schemas.openxmlformats.org/drawingml/2006/main"/>
           <a:p xmlns:a="http://schemas.openxmlformats.org/drawingml/2006/main">
             <a:r>
-              <a:t>Source: supplied Spanish professional portfolio. English translation preserves the stated experience, skills and objectives.</a:t>
+              <a:t>Fuente: Carta_presentacion_deportiva_profesional_v2.pdf, aportado por el usuario. Se conserva el alcance de la experiencia y formación descritas, sin añadir titulaciones ni resultados cuantificados.</a:t>
             </a:r>
           </a:p>
         </p:txBody>
@@ -844,7 +844,7 @@
           <p:cNvPr id="3" name="Title">
             <a:extLst xmlns:a="http://schemas.openxmlformats.org/drawingml/2006/main">
               <a:ext uri="{FF2B5EF4-FFF2-40B4-BE49-F238E27FC236}">
-                <a16:creationId xmlns:a16="http://schemas.microsoft.com/office/drawing/2014/main" id="{26AAF956-5AA5-48AD-B95B-612C9BE9B427}"/>
+                <a16:creationId xmlns:a16="http://schemas.microsoft.com/office/drawing/2014/main" id="{C1B86D34-8D40-4463-8D40-610DF9441483}"/>
               </a:ext>
             </a:extLst>
           </p:cNvPr>
@@ -895,6 +895,7 @@
                 <a:spcPts val="0"/>
               </a:spcAft>
               <a:buNone/>
+              <a:defRPr/>
             </a:lvl1pPr>
             <a:lvl2pPr marL="0" indent="0">
               <a:lnSpc>
@@ -907,6 +908,7 @@
                 <a:spcPts val="0"/>
               </a:spcAft>
               <a:buNone/>
+              <a:defRPr/>
             </a:lvl2pPr>
             <a:lvl3pPr marL="0" indent="0">
               <a:lnSpc>
@@ -919,6 +921,7 @@
                 <a:spcPts val="0"/>
               </a:spcAft>
               <a:buNone/>
+              <a:defRPr/>
             </a:lvl3pPr>
             <a:lvl4pPr marL="0" indent="0">
               <a:lnSpc>
@@ -931,6 +934,7 @@
                 <a:spcPts val="0"/>
               </a:spcAft>
               <a:buNone/>
+              <a:defRPr/>
             </a:lvl4pPr>
             <a:lvl5pPr marL="0" indent="0">
               <a:lnSpc>
@@ -943,6 +947,7 @@
                 <a:spcPts val="0"/>
               </a:spcAft>
               <a:buNone/>
+              <a:defRPr/>
             </a:lvl5pPr>
             <a:lvl6pPr marL="0" indent="0">
               <a:lnSpc>
@@ -955,6 +960,7 @@
                 <a:spcPts val="0"/>
               </a:spcAft>
               <a:buNone/>
+              <a:defRPr/>
             </a:lvl6pPr>
             <a:lvl7pPr marL="0" indent="0">
               <a:lnSpc>
@@ -967,6 +973,7 @@
                 <a:spcPts val="0"/>
               </a:spcAft>
               <a:buNone/>
+              <a:defRPr/>
             </a:lvl7pPr>
             <a:lvl8pPr marL="0" indent="0">
               <a:lnSpc>
@@ -979,6 +986,7 @@
                 <a:spcPts val="0"/>
               </a:spcAft>
               <a:buNone/>
+              <a:defRPr/>
             </a:lvl8pPr>
             <a:lvl9pPr marL="0" indent="0">
               <a:lnSpc>
@@ -991,6 +999,7 @@
                 <a:spcPts val="0"/>
               </a:spcAft>
               <a:buNone/>
+              <a:defRPr/>
             </a:lvl9pPr>
           </a:lstStyle>
           <a:p xmlns:a="http://schemas.openxmlformats.org/drawingml/2006/main"/>
@@ -1001,7 +1010,7 @@
           <p:cNvPr id="2" name="Subtitle">
             <a:extLst xmlns:a="http://schemas.openxmlformats.org/drawingml/2006/main">
               <a:ext uri="{FF2B5EF4-FFF2-40B4-BE49-F238E27FC236}">
-                <a16:creationId xmlns:a16="http://schemas.microsoft.com/office/drawing/2014/main" id="{5C899636-41B5-4426-876C-B8B0B4AED0C9}"/>
+                <a16:creationId xmlns:a16="http://schemas.microsoft.com/office/drawing/2014/main" id="{6AC10FC5-DB05-4855-A923-4398753A6CCE}"/>
               </a:ext>
             </a:extLst>
           </p:cNvPr>
@@ -1052,6 +1061,7 @@
                 <a:spcPts val="0"/>
               </a:spcAft>
               <a:buNone/>
+              <a:defRPr/>
             </a:lvl1pPr>
             <a:lvl2pPr marL="0" indent="0">
               <a:lnSpc>
@@ -1064,6 +1074,7 @@
                 <a:spcPts val="0"/>
               </a:spcAft>
               <a:buNone/>
+              <a:defRPr/>
             </a:lvl2pPr>
             <a:lvl3pPr marL="0" indent="0">
               <a:lnSpc>
@@ -1076,6 +1087,7 @@
                 <a:spcPts val="0"/>
               </a:spcAft>
               <a:buNone/>
+              <a:defRPr/>
             </a:lvl3pPr>
             <a:lvl4pPr marL="0" indent="0">
               <a:lnSpc>
@@ -1088,6 +1100,7 @@
                 <a:spcPts val="0"/>
               </a:spcAft>
               <a:buNone/>
+              <a:defRPr/>
             </a:lvl4pPr>
             <a:lvl5pPr marL="0" indent="0">
               <a:lnSpc>
@@ -1100,6 +1113,7 @@
                 <a:spcPts val="0"/>
               </a:spcAft>
               <a:buNone/>
+              <a:defRPr/>
             </a:lvl5pPr>
             <a:lvl6pPr marL="0" indent="0">
               <a:lnSpc>
@@ -1112,6 +1126,7 @@
                 <a:spcPts val="0"/>
               </a:spcAft>
               <a:buNone/>
+              <a:defRPr/>
             </a:lvl6pPr>
             <a:lvl7pPr marL="0" indent="0">
               <a:lnSpc>
@@ -1124,6 +1139,7 @@
                 <a:spcPts val="0"/>
               </a:spcAft>
               <a:buNone/>
+              <a:defRPr/>
             </a:lvl7pPr>
             <a:lvl8pPr marL="0" indent="0">
               <a:lnSpc>
@@ -1136,6 +1152,7 @@
                 <a:spcPts val="0"/>
               </a:spcAft>
               <a:buNone/>
+              <a:defRPr/>
             </a:lvl8pPr>
             <a:lvl9pPr marL="0" indent="0">
               <a:lnSpc>
@@ -1148,6 +1165,7 @@
                 <a:spcPts val="0"/>
               </a:spcAft>
               <a:buNone/>
+              <a:defRPr/>
             </a:lvl9pPr>
           </a:lstStyle>
           <a:p xmlns:a="http://schemas.openxmlformats.org/drawingml/2006/main"/>
@@ -1175,7 +1193,7 @@
           <p:cNvPr id="2" name="Section title">
             <a:extLst xmlns:a="http://schemas.openxmlformats.org/drawingml/2006/main">
               <a:ext uri="{FF2B5EF4-FFF2-40B4-BE49-F238E27FC236}">
-                <a16:creationId xmlns:a16="http://schemas.microsoft.com/office/drawing/2014/main" id="{C3964FFB-8A70-4C8C-95F5-A7B647AB38ED}"/>
+                <a16:creationId xmlns:a16="http://schemas.microsoft.com/office/drawing/2014/main" id="{826C75A7-9801-4825-9704-3FF49354148B}"/>
               </a:ext>
             </a:extLst>
           </p:cNvPr>
@@ -1226,6 +1244,7 @@
                 <a:spcPts val="0"/>
               </a:spcAft>
               <a:buNone/>
+              <a:defRPr/>
             </a:lvl1pPr>
             <a:lvl2pPr marL="0" indent="0">
               <a:lnSpc>
@@ -1238,6 +1257,7 @@
                 <a:spcPts val="0"/>
               </a:spcAft>
               <a:buNone/>
+              <a:defRPr/>
             </a:lvl2pPr>
             <a:lvl3pPr marL="0" indent="0">
               <a:lnSpc>
@@ -1250,6 +1270,7 @@
                 <a:spcPts val="0"/>
               </a:spcAft>
               <a:buNone/>
+              <a:defRPr/>
             </a:lvl3pPr>
             <a:lvl4pPr marL="0" indent="0">
               <a:lnSpc>
@@ -1262,6 +1283,7 @@
                 <a:spcPts val="0"/>
               </a:spcAft>
               <a:buNone/>
+              <a:defRPr/>
             </a:lvl4pPr>
             <a:lvl5pPr marL="0" indent="0">
               <a:lnSpc>
@@ -1274,6 +1296,7 @@
                 <a:spcPts val="0"/>
               </a:spcAft>
               <a:buNone/>
+              <a:defRPr/>
             </a:lvl5pPr>
             <a:lvl6pPr marL="0" indent="0">
               <a:lnSpc>
@@ -1286,6 +1309,7 @@
                 <a:spcPts val="0"/>
               </a:spcAft>
               <a:buNone/>
+              <a:defRPr/>
             </a:lvl6pPr>
             <a:lvl7pPr marL="0" indent="0">
               <a:lnSpc>
@@ -1298,6 +1322,7 @@
                 <a:spcPts val="0"/>
               </a:spcAft>
               <a:buNone/>
+              <a:defRPr/>
             </a:lvl7pPr>
             <a:lvl8pPr marL="0" indent="0">
               <a:lnSpc>
@@ -1310,6 +1335,7 @@
                 <a:spcPts val="0"/>
               </a:spcAft>
               <a:buNone/>
+              <a:defRPr/>
             </a:lvl8pPr>
             <a:lvl9pPr marL="0" indent="0">
               <a:lnSpc>
@@ -1322,6 +1348,7 @@
                 <a:spcPts val="0"/>
               </a:spcAft>
               <a:buNone/>
+              <a:defRPr/>
             </a:lvl9pPr>
           </a:lstStyle>
           <a:p xmlns:a="http://schemas.openxmlformats.org/drawingml/2006/main"/>
@@ -1349,7 +1376,7 @@
           <p:cNvPr id="3" name="Title">
             <a:extLst xmlns:a="http://schemas.openxmlformats.org/drawingml/2006/main">
               <a:ext uri="{FF2B5EF4-FFF2-40B4-BE49-F238E27FC236}">
-                <a16:creationId xmlns:a16="http://schemas.microsoft.com/office/drawing/2014/main" id="{5CFE71C8-39D2-4BEA-B405-9C400D436A39}"/>
+                <a16:creationId xmlns:a16="http://schemas.microsoft.com/office/drawing/2014/main" id="{3329C540-3001-40E1-9B3C-4C6789322A03}"/>
               </a:ext>
             </a:extLst>
           </p:cNvPr>
@@ -1400,6 +1427,7 @@
                 <a:spcPts val="0"/>
               </a:spcAft>
               <a:buNone/>
+              <a:defRPr/>
             </a:lvl1pPr>
             <a:lvl2pPr marL="0" indent="0">
               <a:lnSpc>
@@ -1412,6 +1440,7 @@
                 <a:spcPts val="0"/>
               </a:spcAft>
               <a:buNone/>
+              <a:defRPr/>
             </a:lvl2pPr>
             <a:lvl3pPr marL="0" indent="0">
               <a:lnSpc>
@@ -1424,6 +1453,7 @@
                 <a:spcPts val="0"/>
               </a:spcAft>
               <a:buNone/>
+              <a:defRPr/>
             </a:lvl3pPr>
             <a:lvl4pPr marL="0" indent="0">
               <a:lnSpc>
@@ -1436,6 +1466,7 @@
                 <a:spcPts val="0"/>
               </a:spcAft>
               <a:buNone/>
+              <a:defRPr/>
             </a:lvl4pPr>
             <a:lvl5pPr marL="0" indent="0">
               <a:lnSpc>
@@ -1448,6 +1479,7 @@
                 <a:spcPts val="0"/>
               </a:spcAft>
               <a:buNone/>
+              <a:defRPr/>
             </a:lvl5pPr>
             <a:lvl6pPr marL="0" indent="0">
               <a:lnSpc>
@@ -1460,6 +1492,7 @@
                 <a:spcPts val="0"/>
               </a:spcAft>
               <a:buNone/>
+              <a:defRPr/>
             </a:lvl6pPr>
             <a:lvl7pPr marL="0" indent="0">
               <a:lnSpc>
@@ -1472,6 +1505,7 @@
                 <a:spcPts val="0"/>
               </a:spcAft>
               <a:buNone/>
+              <a:defRPr/>
             </a:lvl7pPr>
             <a:lvl8pPr marL="0" indent="0">
               <a:lnSpc>
@@ -1484,6 +1518,7 @@
                 <a:spcPts val="0"/>
               </a:spcAft>
               <a:buNone/>
+              <a:defRPr/>
             </a:lvl8pPr>
             <a:lvl9pPr marL="0" indent="0">
               <a:lnSpc>
@@ -1496,6 +1531,7 @@
                 <a:spcPts val="0"/>
               </a:spcAft>
               <a:buNone/>
+              <a:defRPr/>
             </a:lvl9pPr>
           </a:lstStyle>
           <a:p xmlns:a="http://schemas.openxmlformats.org/drawingml/2006/main"/>
@@ -1506,7 +1542,7 @@
           <p:cNvPr id="2" name="Body">
             <a:extLst xmlns:a="http://schemas.openxmlformats.org/drawingml/2006/main">
               <a:ext uri="{FF2B5EF4-FFF2-40B4-BE49-F238E27FC236}">
-                <a16:creationId xmlns:a16="http://schemas.microsoft.com/office/drawing/2014/main" id="{EA9CE487-755F-478A-A65E-D056F4BEC7BA}"/>
+                <a16:creationId xmlns:a16="http://schemas.microsoft.com/office/drawing/2014/main" id="{1644B6D9-D75F-41BA-9E1D-D5F94040F028}"/>
               </a:ext>
             </a:extLst>
           </p:cNvPr>
@@ -1557,6 +1593,7 @@
                 <a:spcPts val="1200"/>
               </a:spcAft>
               <a:buChar char="•"/>
+              <a:defRPr/>
             </a:lvl1pPr>
             <a:lvl2pPr marL="533400" indent="-228600">
               <a:lnSpc>
@@ -1569,6 +1606,7 @@
                 <a:spcPts val="1200"/>
               </a:spcAft>
               <a:buChar char="•"/>
+              <a:defRPr/>
             </a:lvl2pPr>
             <a:lvl3pPr marL="838200" indent="-228600">
               <a:lnSpc>
@@ -1581,6 +1619,7 @@
                 <a:spcPts val="1200"/>
               </a:spcAft>
               <a:buChar char="•"/>
+              <a:defRPr/>
             </a:lvl3pPr>
             <a:lvl4pPr marL="1143000" indent="-228600">
               <a:lnSpc>
@@ -1593,6 +1632,7 @@
                 <a:spcPts val="1200"/>
               </a:spcAft>
               <a:buChar char="•"/>
+              <a:defRPr/>
             </a:lvl4pPr>
             <a:lvl5pPr marL="1447800" indent="-228600">
               <a:lnSpc>
@@ -1605,6 +1645,7 @@
                 <a:spcPts val="1200"/>
               </a:spcAft>
               <a:buChar char="•"/>
+              <a:defRPr/>
             </a:lvl5pPr>
             <a:lvl6pPr marL="1752600" indent="-228600">
               <a:lnSpc>
@@ -1617,6 +1658,7 @@
                 <a:spcPts val="1200"/>
               </a:spcAft>
               <a:buChar char="•"/>
+              <a:defRPr/>
             </a:lvl6pPr>
             <a:lvl7pPr marL="2057400" indent="-228600">
               <a:lnSpc>
@@ -1629,6 +1671,7 @@
                 <a:spcPts val="1200"/>
               </a:spcAft>
               <a:buChar char="•"/>
+              <a:defRPr/>
             </a:lvl7pPr>
             <a:lvl8pPr marL="2362200" indent="-228600">
               <a:lnSpc>
@@ -1641,6 +1684,7 @@
                 <a:spcPts val="1200"/>
               </a:spcAft>
               <a:buChar char="•"/>
+              <a:defRPr/>
             </a:lvl8pPr>
             <a:lvl9pPr marL="2667000" indent="-228600">
               <a:lnSpc>
@@ -1653,6 +1697,7 @@
                 <a:spcPts val="1200"/>
               </a:spcAft>
               <a:buChar char="•"/>
+              <a:defRPr/>
             </a:lvl9pPr>
           </a:lstStyle>
           <a:p xmlns:a="http://schemas.openxmlformats.org/drawingml/2006/main"/>
@@ -1680,7 +1725,7 @@
           <p:cNvPr id="4" name="Title">
             <a:extLst xmlns:a="http://schemas.openxmlformats.org/drawingml/2006/main">
               <a:ext uri="{FF2B5EF4-FFF2-40B4-BE49-F238E27FC236}">
-                <a16:creationId xmlns:a16="http://schemas.microsoft.com/office/drawing/2014/main" id="{3C59B46C-B0AE-498B-A715-2BF4D3BFD400}"/>
+                <a16:creationId xmlns:a16="http://schemas.microsoft.com/office/drawing/2014/main" id="{42E0EA3C-E58C-4F4D-AC7A-DCCC21E4D80C}"/>
               </a:ext>
             </a:extLst>
           </p:cNvPr>
@@ -1731,6 +1776,7 @@
                 <a:spcPts val="0"/>
               </a:spcAft>
               <a:buNone/>
+              <a:defRPr/>
             </a:lvl1pPr>
             <a:lvl2pPr marL="0" indent="0">
               <a:lnSpc>
@@ -1743,6 +1789,7 @@
                 <a:spcPts val="0"/>
               </a:spcAft>
               <a:buNone/>
+              <a:defRPr/>
             </a:lvl2pPr>
             <a:lvl3pPr marL="0" indent="0">
               <a:lnSpc>
@@ -1755,6 +1802,7 @@
                 <a:spcPts val="0"/>
               </a:spcAft>
               <a:buNone/>
+              <a:defRPr/>
             </a:lvl3pPr>
             <a:lvl4pPr marL="0" indent="0">
               <a:lnSpc>
@@ -1767,6 +1815,7 @@
                 <a:spcPts val="0"/>
               </a:spcAft>
               <a:buNone/>
+              <a:defRPr/>
             </a:lvl4pPr>
             <a:lvl5pPr marL="0" indent="0">
               <a:lnSpc>
@@ -1779,6 +1828,7 @@
                 <a:spcPts val="0"/>
               </a:spcAft>
               <a:buNone/>
+              <a:defRPr/>
             </a:lvl5pPr>
             <a:lvl6pPr marL="0" indent="0">
               <a:lnSpc>
@@ -1791,6 +1841,7 @@
                 <a:spcPts val="0"/>
               </a:spcAft>
               <a:buNone/>
+              <a:defRPr/>
             </a:lvl6pPr>
             <a:lvl7pPr marL="0" indent="0">
               <a:lnSpc>
@@ -1803,6 +1854,7 @@
                 <a:spcPts val="0"/>
               </a:spcAft>
               <a:buNone/>
+              <a:defRPr/>
             </a:lvl7pPr>
             <a:lvl8pPr marL="0" indent="0">
               <a:lnSpc>
@@ -1815,6 +1867,7 @@
                 <a:spcPts val="0"/>
               </a:spcAft>
               <a:buNone/>
+              <a:defRPr/>
             </a:lvl8pPr>
             <a:lvl9pPr marL="0" indent="0">
               <a:lnSpc>
@@ -1827,6 +1880,7 @@
                 <a:spcPts val="0"/>
               </a:spcAft>
               <a:buNone/>
+              <a:defRPr/>
             </a:lvl9pPr>
           </a:lstStyle>
           <a:p xmlns:a="http://schemas.openxmlformats.org/drawingml/2006/main"/>
@@ -1837,7 +1891,7 @@
           <p:cNvPr id="2" name="Left column">
             <a:extLst xmlns:a="http://schemas.openxmlformats.org/drawingml/2006/main">
               <a:ext uri="{FF2B5EF4-FFF2-40B4-BE49-F238E27FC236}">
-                <a16:creationId xmlns:a16="http://schemas.microsoft.com/office/drawing/2014/main" id="{2628E435-162E-432A-B7DC-05BE2B5845A2}"/>
+                <a16:creationId xmlns:a16="http://schemas.microsoft.com/office/drawing/2014/main" id="{3756614C-2F6D-4D79-B0F0-D195A9D5C95B}"/>
               </a:ext>
             </a:extLst>
           </p:cNvPr>
@@ -1888,6 +1942,7 @@
                 <a:spcPts val="1200"/>
               </a:spcAft>
               <a:buChar char="•"/>
+              <a:defRPr/>
             </a:lvl1pPr>
             <a:lvl2pPr marL="533400" indent="-228600">
               <a:lnSpc>
@@ -1900,6 +1955,7 @@
                 <a:spcPts val="1200"/>
               </a:spcAft>
               <a:buChar char="•"/>
+              <a:defRPr/>
             </a:lvl2pPr>
             <a:lvl3pPr marL="838200" indent="-228600">
               <a:lnSpc>
@@ -1912,6 +1968,7 @@
                 <a:spcPts val="1200"/>
               </a:spcAft>
               <a:buChar char="•"/>
+              <a:defRPr/>
             </a:lvl3pPr>
             <a:lvl4pPr marL="1143000" indent="-228600">
               <a:lnSpc>
@@ -1924,6 +1981,7 @@
                 <a:spcPts val="1200"/>
               </a:spcAft>
               <a:buChar char="•"/>
+              <a:defRPr/>
             </a:lvl4pPr>
             <a:lvl5pPr marL="1447800" indent="-228600">
               <a:lnSpc>
@@ -1936,6 +1994,7 @@
                 <a:spcPts val="1200"/>
               </a:spcAft>
               <a:buChar char="•"/>
+              <a:defRPr/>
             </a:lvl5pPr>
             <a:lvl6pPr marL="1752600" indent="-228600">
               <a:lnSpc>
@@ -1948,6 +2007,7 @@
                 <a:spcPts val="1200"/>
               </a:spcAft>
               <a:buChar char="•"/>
+              <a:defRPr/>
             </a:lvl6pPr>
             <a:lvl7pPr marL="2057400" indent="-228600">
               <a:lnSpc>
@@ -1960,6 +2020,7 @@
                 <a:spcPts val="1200"/>
               </a:spcAft>
               <a:buChar char="•"/>
+              <a:defRPr/>
             </a:lvl7pPr>
             <a:lvl8pPr marL="2362200" indent="-228600">
               <a:lnSpc>
@@ -1972,6 +2033,7 @@
                 <a:spcPts val="1200"/>
               </a:spcAft>
               <a:buChar char="•"/>
+              <a:defRPr/>
             </a:lvl8pPr>
             <a:lvl9pPr marL="2667000" indent="-228600">
               <a:lnSpc>
@@ -1984,6 +2046,7 @@
                 <a:spcPts val="1200"/>
               </a:spcAft>
               <a:buChar char="•"/>
+              <a:defRPr/>
             </a:lvl9pPr>
           </a:lstStyle>
           <a:p xmlns:a="http://schemas.openxmlformats.org/drawingml/2006/main"/>
@@ -1994,7 +2057,7 @@
           <p:cNvPr id="3" name="Right column">
             <a:extLst xmlns:a="http://schemas.openxmlformats.org/drawingml/2006/main">
               <a:ext uri="{FF2B5EF4-FFF2-40B4-BE49-F238E27FC236}">
-                <a16:creationId xmlns:a16="http://schemas.microsoft.com/office/drawing/2014/main" id="{B5D0C42A-1840-4C6F-BDD5-3F1DE661108D}"/>
+                <a16:creationId xmlns:a16="http://schemas.microsoft.com/office/drawing/2014/main" id="{64FE53AA-DAEC-4CDC-A0F0-27C48637FA2E}"/>
               </a:ext>
             </a:extLst>
           </p:cNvPr>
@@ -2045,6 +2108,7 @@
                 <a:spcPts val="1200"/>
               </a:spcAft>
               <a:buChar char="•"/>
+              <a:defRPr/>
             </a:lvl1pPr>
             <a:lvl2pPr marL="533400" indent="-228600">
               <a:lnSpc>
@@ -2057,6 +2121,7 @@
                 <a:spcPts val="1200"/>
               </a:spcAft>
               <a:buChar char="•"/>
+              <a:defRPr/>
             </a:lvl2pPr>
             <a:lvl3pPr marL="838200" indent="-228600">
               <a:lnSpc>
@@ -2069,6 +2134,7 @@
                 <a:spcPts val="1200"/>
               </a:spcAft>
               <a:buChar char="•"/>
+              <a:defRPr/>
             </a:lvl3pPr>
             <a:lvl4pPr marL="1143000" indent="-228600">
               <a:lnSpc>
@@ -2081,6 +2147,7 @@
                 <a:spcPts val="1200"/>
               </a:spcAft>
               <a:buChar char="•"/>
+              <a:defRPr/>
             </a:lvl4pPr>
             <a:lvl5pPr marL="1447800" indent="-228600">
               <a:lnSpc>
@@ -2093,6 +2160,7 @@
                 <a:spcPts val="1200"/>
               </a:spcAft>
               <a:buChar char="•"/>
+              <a:defRPr/>
             </a:lvl5pPr>
             <a:lvl6pPr marL="1752600" indent="-228600">
               <a:lnSpc>
@@ -2105,6 +2173,7 @@
                 <a:spcPts val="1200"/>
               </a:spcAft>
               <a:buChar char="•"/>
+              <a:defRPr/>
             </a:lvl6pPr>
             <a:lvl7pPr marL="2057400" indent="-228600">
               <a:lnSpc>
@@ -2117,6 +2186,7 @@
                 <a:spcPts val="1200"/>
               </a:spcAft>
               <a:buChar char="•"/>
+              <a:defRPr/>
             </a:lvl7pPr>
             <a:lvl8pPr marL="2362200" indent="-228600">
               <a:lnSpc>
@@ -2129,6 +2199,7 @@
                 <a:spcPts val="1200"/>
               </a:spcAft>
               <a:buChar char="•"/>
+              <a:defRPr/>
             </a:lvl8pPr>
             <a:lvl9pPr marL="2667000" indent="-228600">
               <a:lnSpc>
@@ -2141,6 +2212,7 @@
                 <a:spcPts val="1200"/>
               </a:spcAft>
               <a:buChar char="•"/>
+              <a:defRPr/>
             </a:lvl9pPr>
           </a:lstStyle>
           <a:p xmlns:a="http://schemas.openxmlformats.org/drawingml/2006/main"/>
@@ -2168,7 +2240,7 @@
           <p:cNvPr id="3" name="Title">
             <a:extLst xmlns:a="http://schemas.openxmlformats.org/drawingml/2006/main">
               <a:ext uri="{FF2B5EF4-FFF2-40B4-BE49-F238E27FC236}">
-                <a16:creationId xmlns:a16="http://schemas.microsoft.com/office/drawing/2014/main" id="{F70A6497-44DF-49EF-9FD4-9FCD9BA766A6}"/>
+                <a16:creationId xmlns:a16="http://schemas.microsoft.com/office/drawing/2014/main" id="{8643FF3B-FDF3-48E9-92C5-140BB61567B0}"/>
               </a:ext>
             </a:extLst>
           </p:cNvPr>
@@ -2219,6 +2291,7 @@
                 <a:spcPts val="0"/>
               </a:spcAft>
               <a:buNone/>
+              <a:defRPr/>
             </a:lvl1pPr>
             <a:lvl2pPr marL="0" indent="0">
               <a:lnSpc>
@@ -2231,6 +2304,7 @@
                 <a:spcPts val="0"/>
               </a:spcAft>
               <a:buNone/>
+              <a:defRPr/>
             </a:lvl2pPr>
             <a:lvl3pPr marL="0" indent="0">
               <a:lnSpc>
@@ -2243,6 +2317,7 @@
                 <a:spcPts val="0"/>
               </a:spcAft>
               <a:buNone/>
+              <a:defRPr/>
             </a:lvl3pPr>
             <a:lvl4pPr marL="0" indent="0">
               <a:lnSpc>
@@ -2255,6 +2330,7 @@
                 <a:spcPts val="0"/>
               </a:spcAft>
               <a:buNone/>
+              <a:defRPr/>
             </a:lvl4pPr>
             <a:lvl5pPr marL="0" indent="0">
               <a:lnSpc>
@@ -2267,6 +2343,7 @@
                 <a:spcPts val="0"/>
               </a:spcAft>
               <a:buNone/>
+              <a:defRPr/>
             </a:lvl5pPr>
             <a:lvl6pPr marL="0" indent="0">
               <a:lnSpc>
@@ -2279,6 +2356,7 @@
                 <a:spcPts val="0"/>
               </a:spcAft>
               <a:buNone/>
+              <a:defRPr/>
             </a:lvl6pPr>
             <a:lvl7pPr marL="0" indent="0">
               <a:lnSpc>
@@ -2291,6 +2369,7 @@
                 <a:spcPts val="0"/>
               </a:spcAft>
               <a:buNone/>
+              <a:defRPr/>
             </a:lvl7pPr>
             <a:lvl8pPr marL="0" indent="0">
               <a:lnSpc>
@@ -2303,6 +2382,7 @@
                 <a:spcPts val="0"/>
               </a:spcAft>
               <a:buNone/>
+              <a:defRPr/>
             </a:lvl8pPr>
             <a:lvl9pPr marL="0" indent="0">
               <a:lnSpc>
@@ -2315,6 +2395,7 @@
                 <a:spcPts val="0"/>
               </a:spcAft>
               <a:buNone/>
+              <a:defRPr/>
             </a:lvl9pPr>
           </a:lstStyle>
           <a:p xmlns:a="http://schemas.openxmlformats.org/drawingml/2006/main"/>
@@ -2325,7 +2406,7 @@
           <p:cNvPr id="2" name="Left column">
             <a:extLst xmlns:a="http://schemas.openxmlformats.org/drawingml/2006/main">
               <a:ext uri="{FF2B5EF4-FFF2-40B4-BE49-F238E27FC236}">
-                <a16:creationId xmlns:a16="http://schemas.microsoft.com/office/drawing/2014/main" id="{E73E35DD-307D-4CCE-8B55-E964D147BAD8}"/>
+                <a16:creationId xmlns:a16="http://schemas.microsoft.com/office/drawing/2014/main" id="{C3C3955A-2E5C-41F1-B94C-726ABADF464E}"/>
               </a:ext>
             </a:extLst>
           </p:cNvPr>
@@ -2376,6 +2457,7 @@
                 <a:spcPts val="1200"/>
               </a:spcAft>
               <a:buChar char="•"/>
+              <a:defRPr/>
             </a:lvl1pPr>
             <a:lvl2pPr marL="533400" indent="-228600">
               <a:lnSpc>
@@ -2388,6 +2470,7 @@
                 <a:spcPts val="1200"/>
               </a:spcAft>
               <a:buChar char="•"/>
+              <a:defRPr/>
             </a:lvl2pPr>
             <a:lvl3pPr marL="838200" indent="-228600">
               <a:lnSpc>
@@ -2400,6 +2483,7 @@
                 <a:spcPts val="1200"/>
               </a:spcAft>
               <a:buChar char="•"/>
+              <a:defRPr/>
             </a:lvl3pPr>
             <a:lvl4pPr marL="1143000" indent="-228600">
               <a:lnSpc>
@@ -2412,6 +2496,7 @@
                 <a:spcPts val="1200"/>
               </a:spcAft>
               <a:buChar char="•"/>
+              <a:defRPr/>
             </a:lvl4pPr>
             <a:lvl5pPr marL="1447800" indent="-228600">
               <a:lnSpc>
@@ -2424,6 +2509,7 @@
                 <a:spcPts val="1200"/>
               </a:spcAft>
               <a:buChar char="•"/>
+              <a:defRPr/>
             </a:lvl5pPr>
             <a:lvl6pPr marL="1752600" indent="-228600">
               <a:lnSpc>
@@ -2436,6 +2522,7 @@
                 <a:spcPts val="1200"/>
               </a:spcAft>
               <a:buChar char="•"/>
+              <a:defRPr/>
             </a:lvl6pPr>
             <a:lvl7pPr marL="2057400" indent="-228600">
               <a:lnSpc>
@@ -2448,6 +2535,7 @@
                 <a:spcPts val="1200"/>
               </a:spcAft>
               <a:buChar char="•"/>
+              <a:defRPr/>
             </a:lvl7pPr>
             <a:lvl8pPr marL="2362200" indent="-228600">
               <a:lnSpc>
@@ -2460,6 +2548,7 @@
                 <a:spcPts val="1200"/>
               </a:spcAft>
               <a:buChar char="•"/>
+              <a:defRPr/>
             </a:lvl8pPr>
             <a:lvl9pPr marL="2667000" indent="-228600">
               <a:lnSpc>
@@ -2472,6 +2561,7 @@
                 <a:spcPts val="1200"/>
               </a:spcAft>
               <a:buChar char="•"/>
+              <a:defRPr/>
             </a:lvl9pPr>
           </a:lstStyle>
           <a:p xmlns:a="http://schemas.openxmlformats.org/drawingml/2006/main"/>
@@ -2520,12 +2610,12 @@
   </p:cSld>
   <p:clrMap bg1="lt1" tx1="dk1" bg2="lt2" tx2="dk2" accent1="accent1" accent2="accent2" accent3="accent3" accent4="accent4" accent5="accent5" accent6="accent6" hlink="hlink" folHlink="folHlink"/>
   <p:sldLayoutIdLst>
-    <p:sldLayoutId xmlns:r="http://schemas.openxmlformats.org/officeDocument/2006/relationships" id="2147483649" r:id="R5d54897effdf4076"/>
-    <p:sldLayoutId xmlns:r="http://schemas.openxmlformats.org/officeDocument/2006/relationships" id="2147483650" r:id="R169b81bdc2594c96"/>
-    <p:sldLayoutId xmlns:r="http://schemas.openxmlformats.org/officeDocument/2006/relationships" id="2147483651" r:id="R67ec20bf5cb84966"/>
-    <p:sldLayoutId xmlns:r="http://schemas.openxmlformats.org/officeDocument/2006/relationships" id="2147483652" r:id="Rf3fa578475f54607"/>
-    <p:sldLayoutId xmlns:r="http://schemas.openxmlformats.org/officeDocument/2006/relationships" id="2147483653" r:id="Rb56bc96cc9a541ae"/>
-    <p:sldLayoutId xmlns:r="http://schemas.openxmlformats.org/officeDocument/2006/relationships" id="2147483654" r:id="Rb2672c40a5204365"/>
+    <p:sldLayoutId xmlns:r="http://schemas.openxmlformats.org/officeDocument/2006/relationships" id="2147483649" r:id="Rc7bede88bc284381"/>
+    <p:sldLayoutId xmlns:r="http://schemas.openxmlformats.org/officeDocument/2006/relationships" id="2147483650" r:id="R942517a0dff44607"/>
+    <p:sldLayoutId xmlns:r="http://schemas.openxmlformats.org/officeDocument/2006/relationships" id="2147483651" r:id="R2ba4cc0ad45b42a4"/>
+    <p:sldLayoutId xmlns:r="http://schemas.openxmlformats.org/officeDocument/2006/relationships" id="2147483652" r:id="Rb2e4fa77182846ff"/>
+    <p:sldLayoutId xmlns:r="http://schemas.openxmlformats.org/officeDocument/2006/relationships" id="2147483653" r:id="R9c514eb08ca74f74"/>
+    <p:sldLayoutId xmlns:r="http://schemas.openxmlformats.org/officeDocument/2006/relationships" id="2147483654" r:id="R8f24c5aa06704a9a"/>
   </p:sldLayoutIdLst>
   <p:txStyles>
     <p:titleStyle>
@@ -3076,7 +3166,7 @@
           <p:cNvPr id="6" name="">
             <a:extLst xmlns:a="http://schemas.openxmlformats.org/drawingml/2006/main">
               <a:ext uri="{FF2B5EF4-FFF2-40B4-BE49-F238E27FC236}">
-                <a16:creationId xmlns:a16="http://schemas.microsoft.com/office/drawing/2014/main" id="{86850411-4F5C-44E0-A2F9-56B896B2887B}"/>
+                <a16:creationId xmlns:a16="http://schemas.microsoft.com/office/drawing/2014/main" id="{3C1982B7-A5DE-40A0-92C9-15BD14EC2420}"/>
               </a:ext>
             </a:extLst>
           </p:cNvPr>
@@ -3086,13 +3176,13 @@
           <p:nvPr/>
         </p:nvPicPr>
         <p:blipFill>
-          <a:blip xmlns:r="http://schemas.openxmlformats.org/officeDocument/2006/relationships" xmlns:a="http://schemas.openxmlformats.org/drawingml/2006/main" r:embed="R155eddb496c747a5"/>
+          <a:blip xmlns:r="http://schemas.openxmlformats.org/officeDocument/2006/relationships" xmlns:a="http://schemas.openxmlformats.org/drawingml/2006/main" r:embed="R9812459ddc1d4ba3"/>
           <a:stretch xmlns:a="http://schemas.openxmlformats.org/drawingml/2006/main"/>
         </p:blipFill>
         <p:spPr>
           <a:xfrm xmlns:a="http://schemas.openxmlformats.org/drawingml/2006/main">
-            <a:off x="6777038" y="619125"/>
-            <a:ext cx="4495800" cy="5619750"/>
+            <a:off x="6810375" y="571500"/>
+            <a:ext cx="4572000" cy="5715000"/>
           </a:xfrm>
           <a:prstGeom xmlns:a="http://schemas.openxmlformats.org/drawingml/2006/main" prst="rect">
             <a:avLst/>
@@ -3104,7 +3194,7 @@
           <p:cNvPr id="2" name="">
             <a:extLst xmlns:a="http://schemas.openxmlformats.org/drawingml/2006/main">
               <a:ext uri="{FF2B5EF4-FFF2-40B4-BE49-F238E27FC236}">
-                <a16:creationId xmlns:a16="http://schemas.microsoft.com/office/drawing/2014/main" id="{011E32E5-C07C-414E-86D3-B08D9792F313}"/>
+                <a16:creationId xmlns:a16="http://schemas.microsoft.com/office/drawing/2014/main" id="{C139F0D1-9959-4207-884D-83175B0061C1}"/>
               </a:ext>
             </a:extLst>
           </p:cNvPr>
@@ -3115,8 +3205,8 @@
         </p:nvSpPr>
         <p:spPr>
           <a:xfrm xmlns:a="http://schemas.openxmlformats.org/drawingml/2006/main">
-            <a:off x="609600" y="828675"/>
-            <a:ext cx="5619750" cy="476250"/>
+            <a:off x="609600" y="819150"/>
+            <a:ext cx="5715000" cy="428625"/>
           </a:xfrm>
           <a:prstGeom xmlns:a="http://schemas.openxmlformats.org/drawingml/2006/main" prst="rect">
             <a:avLst/>
@@ -3129,7 +3219,7 @@
         <p:txBody>
           <a:bodyPr xmlns:a="http://schemas.openxmlformats.org/drawingml/2006/main"/>
           <a:lstStyle xmlns:a="http://schemas.openxmlformats.org/drawingml/2006/main">
-            <a:defPPr>
+            <a:defPPr algn="l">
               <a:defRPr sz="1800" b="1">
                 <a:solidFill>
                   <a:srgbClr val="FFFFFF"/>
@@ -3141,7 +3231,8 @@
             </a:defPPr>
           </a:lstStyle>
           <a:p xmlns:a="http://schemas.openxmlformats.org/drawingml/2006/main">
-            <a:pPr>
+            <a:pPr algn="l">
+              <a:buNone/>
               <a:defRPr sz="1800" b="1">
                 <a:solidFill>
                   <a:srgbClr val="FFFFFF"/>
@@ -3170,7 +3261,7 @@
           <p:cNvPr id="3" name="">
             <a:extLst xmlns:a="http://schemas.openxmlformats.org/drawingml/2006/main">
               <a:ext uri="{FF2B5EF4-FFF2-40B4-BE49-F238E27FC236}">
-                <a16:creationId xmlns:a16="http://schemas.microsoft.com/office/drawing/2014/main" id="{5CDB6B76-5A80-47D3-AC61-1984CBE086D8}"/>
+                <a16:creationId xmlns:a16="http://schemas.microsoft.com/office/drawing/2014/main" id="{04CDBB97-681F-4C04-AF0C-BDEEC4E9FF05}"/>
               </a:ext>
             </a:extLst>
           </p:cNvPr>
@@ -3181,8 +3272,8 @@
         </p:nvSpPr>
         <p:spPr>
           <a:xfrm xmlns:a="http://schemas.openxmlformats.org/drawingml/2006/main">
-            <a:off x="609600" y="1809750"/>
-            <a:ext cx="5715000" cy="1524000"/>
+            <a:off x="609600" y="1838325"/>
+            <a:ext cx="5810250" cy="1524000"/>
           </a:xfrm>
           <a:prstGeom xmlns:a="http://schemas.openxmlformats.org/drawingml/2006/main" prst="rect">
             <a:avLst/>
@@ -3208,6 +3299,7 @@
           </a:lstStyle>
           <a:p xmlns:a="http://schemas.openxmlformats.org/drawingml/2006/main">
             <a:pPr>
+              <a:buNone/>
               <a:defRPr sz="3600" b="1">
                 <a:solidFill>
                   <a:srgbClr val="FFFFFF"/>
@@ -3231,6 +3323,7 @@
           </a:p>
           <a:p xmlns:a="http://schemas.openxmlformats.org/drawingml/2006/main">
             <a:pPr>
+              <a:buNone/>
               <a:defRPr sz="3600" b="1">
                 <a:solidFill>
                   <a:srgbClr val="FFFFFF"/>
@@ -3259,7 +3352,7 @@
           <p:cNvPr id="4" name="">
             <a:extLst xmlns:a="http://schemas.openxmlformats.org/drawingml/2006/main">
               <a:ext uri="{FF2B5EF4-FFF2-40B4-BE49-F238E27FC236}">
-                <a16:creationId xmlns:a16="http://schemas.microsoft.com/office/drawing/2014/main" id="{C3329A59-49A8-4CAC-B793-00D9A6E03190}"/>
+                <a16:creationId xmlns:a16="http://schemas.microsoft.com/office/drawing/2014/main" id="{3AE502FD-CFE2-4FB9-9816-E10EACEE1F09}"/>
               </a:ext>
             </a:extLst>
           </p:cNvPr>
@@ -3270,8 +3363,8 @@
         </p:nvSpPr>
         <p:spPr>
           <a:xfrm xmlns:a="http://schemas.openxmlformats.org/drawingml/2006/main">
-            <a:off x="609600" y="3838575"/>
-            <a:ext cx="5524500" cy="1143000"/>
+            <a:off x="609600" y="3771900"/>
+            <a:ext cx="5715000" cy="1095375"/>
           </a:xfrm>
           <a:prstGeom xmlns:a="http://schemas.openxmlformats.org/drawingml/2006/main" prst="rect">
             <a:avLst/>
@@ -3284,7 +3377,7 @@
         <p:txBody>
           <a:bodyPr xmlns:a="http://schemas.openxmlformats.org/drawingml/2006/main"/>
           <a:lstStyle xmlns:a="http://schemas.openxmlformats.org/drawingml/2006/main">
-            <a:defPPr>
+            <a:defPPr algn="l">
               <a:defRPr sz="2400" b="0">
                 <a:solidFill>
                   <a:srgbClr val="FFFFFF"/>
@@ -3296,7 +3389,8 @@
             </a:defPPr>
           </a:lstStyle>
           <a:p xmlns:a="http://schemas.openxmlformats.org/drawingml/2006/main">
-            <a:pPr>
+            <a:pPr algn="l">
+              <a:buNone/>
               <a:defRPr sz="2400" b="0">
                 <a:solidFill>
                   <a:srgbClr val="FFFFFF"/>
@@ -3319,7 +3413,8 @@
             </a:r>
           </a:p>
           <a:p xmlns:a="http://schemas.openxmlformats.org/drawingml/2006/main">
-            <a:pPr>
+            <a:pPr algn="l">
+              <a:buNone/>
               <a:defRPr sz="2400" b="0">
                 <a:solidFill>
                   <a:srgbClr val="FFFFFF"/>
@@ -3348,7 +3443,7 @@
           <p:cNvPr id="5" name="">
             <a:extLst xmlns:a="http://schemas.openxmlformats.org/drawingml/2006/main">
               <a:ext uri="{FF2B5EF4-FFF2-40B4-BE49-F238E27FC236}">
-                <a16:creationId xmlns:a16="http://schemas.microsoft.com/office/drawing/2014/main" id="{194ED10D-6BAD-4A8D-B8E3-62F6A2B6BE22}"/>
+                <a16:creationId xmlns:a16="http://schemas.microsoft.com/office/drawing/2014/main" id="{914262D0-10A3-4881-9022-BB0671C88588}"/>
               </a:ext>
             </a:extLst>
           </p:cNvPr>
@@ -3359,8 +3454,8 @@
         </p:nvSpPr>
         <p:spPr>
           <a:xfrm xmlns:a="http://schemas.openxmlformats.org/drawingml/2006/main">
-            <a:off x="609600" y="5305425"/>
-            <a:ext cx="5524500" cy="952500"/>
+            <a:off x="609600" y="5238750"/>
+            <a:ext cx="5715000" cy="857250"/>
           </a:xfrm>
           <a:prstGeom xmlns:a="http://schemas.openxmlformats.org/drawingml/2006/main" prst="rect">
             <a:avLst/>
@@ -3373,7 +3468,7 @@
         <p:txBody>
           <a:bodyPr xmlns:a="http://schemas.openxmlformats.org/drawingml/2006/main"/>
           <a:lstStyle xmlns:a="http://schemas.openxmlformats.org/drawingml/2006/main">
-            <a:defPPr>
+            <a:defPPr algn="l">
               <a:defRPr sz="1950" b="0">
                 <a:solidFill>
                   <a:srgbClr val="FFFFFF"/>
@@ -3385,7 +3480,8 @@
             </a:defPPr>
           </a:lstStyle>
           <a:p xmlns:a="http://schemas.openxmlformats.org/drawingml/2006/main">
-            <a:pPr>
+            <a:pPr algn="l">
+              <a:buNone/>
               <a:defRPr sz="1950" b="0">
                 <a:solidFill>
                   <a:srgbClr val="FFFFFF"/>
@@ -3408,7 +3504,8 @@
             </a:r>
           </a:p>
           <a:p xmlns:a="http://schemas.openxmlformats.org/drawingml/2006/main">
-            <a:pPr>
+            <a:pPr algn="l">
+              <a:buNone/>
               <a:defRPr sz="1950" b="0">
                 <a:solidFill>
                   <a:srgbClr val="FFFFFF"/>
@@ -3435,7 +3532,7 @@
     </p:spTree>
     <p:extLst>
       <p:ext uri="{BB962C8B-B14F-4D97-AF65-F5344CB8AC3E}">
-        <p14:creationId xmlns:p14="http://schemas.microsoft.com/office/powerpoint/2010/main" val="934277247"/>
+        <p14:creationId xmlns:p14="http://schemas.microsoft.com/office/powerpoint/2010/main" val="2033915637"/>
       </p:ext>
     </p:extLst>
   </p:cSld>
@@ -3466,7 +3563,7 @@
           <p:cNvPr id="6" name="">
             <a:extLst xmlns:a="http://schemas.openxmlformats.org/drawingml/2006/main">
               <a:ext uri="{FF2B5EF4-FFF2-40B4-BE49-F238E27FC236}">
-                <a16:creationId xmlns:a16="http://schemas.microsoft.com/office/drawing/2014/main" id="{8BC1FDD6-7BD5-404B-A2A5-3B18ED3E4F62}"/>
+                <a16:creationId xmlns:a16="http://schemas.microsoft.com/office/drawing/2014/main" id="{72B314AE-E6CD-43D6-82DE-2C62A1993DB5}"/>
               </a:ext>
             </a:extLst>
           </p:cNvPr>
@@ -3491,8 +3588,8 @@
         <p:txBody>
           <a:bodyPr xmlns:a="http://schemas.openxmlformats.org/drawingml/2006/main"/>
           <a:lstStyle xmlns:a="http://schemas.openxmlformats.org/drawingml/2006/main">
-            <a:defPPr>
-              <a:defRPr sz="3225" b="1">
+            <a:defPPr algn="l">
+              <a:defRPr sz="3300" b="1">
                 <a:solidFill>
                   <a:srgbClr val="213C31"/>
                 </a:solidFill>
@@ -3503,8 +3600,9 @@
             </a:defPPr>
           </a:lstStyle>
           <a:p xmlns:a="http://schemas.openxmlformats.org/drawingml/2006/main">
-            <a:pPr>
-              <a:defRPr sz="3225" b="1">
+            <a:pPr algn="l">
+              <a:buNone/>
+              <a:defRPr sz="3300" b="1">
                 <a:solidFill>
                   <a:srgbClr val="213C31"/>
                 </a:solidFill>
@@ -3514,7 +3612,7 @@
               </a:defRPr>
             </a:pPr>
             <a:r>
-              <a:rPr sz="3225" b="1">
+              <a:rPr sz="3300" b="1">
                 <a:solidFill>
                   <a:srgbClr val="213C31"/>
                 </a:solidFill>
@@ -3532,7 +3630,7 @@
           <p:cNvPr id="2" name="">
             <a:extLst xmlns:a="http://schemas.openxmlformats.org/drawingml/2006/main">
               <a:ext uri="{FF2B5EF4-FFF2-40B4-BE49-F238E27FC236}">
-                <a16:creationId xmlns:a16="http://schemas.microsoft.com/office/drawing/2014/main" id="{8E9608B7-C439-4AE8-961A-6CC14C09C367}"/>
+                <a16:creationId xmlns:a16="http://schemas.microsoft.com/office/drawing/2014/main" id="{253453CA-A7E4-4AD0-80D8-66DFA5D0CA4D}"/>
               </a:ext>
             </a:extLst>
           </p:cNvPr>
@@ -3570,6 +3668,7 @@
           </a:lstStyle>
           <a:p xmlns:a="http://schemas.openxmlformats.org/drawingml/2006/main">
             <a:pPr>
+              <a:buNone/>
               <a:defRPr sz="1350" b="0">
                 <a:solidFill>
                   <a:srgbClr val="55645B"/>
@@ -3598,7 +3697,7 @@
           <p:cNvPr id="3" name="">
             <a:extLst xmlns:a="http://schemas.openxmlformats.org/drawingml/2006/main">
               <a:ext uri="{FF2B5EF4-FFF2-40B4-BE49-F238E27FC236}">
-                <a16:creationId xmlns:a16="http://schemas.microsoft.com/office/drawing/2014/main" id="{EFDBF3F0-CD8D-4C3D-96AB-A31988F4514B}"/>
+                <a16:creationId xmlns:a16="http://schemas.microsoft.com/office/drawing/2014/main" id="{EFFDA917-1684-4820-B3FC-34BA032CBA6F}"/>
               </a:ext>
             </a:extLst>
           </p:cNvPr>
@@ -3609,8 +3708,8 @@
         </p:nvSpPr>
         <p:spPr>
           <a:xfrm xmlns:a="http://schemas.openxmlformats.org/drawingml/2006/main">
-            <a:off x="685800" y="1762125"/>
-            <a:ext cx="10477500" cy="857250"/>
+            <a:off x="685800" y="1828800"/>
+            <a:ext cx="10477500" cy="762000"/>
           </a:xfrm>
           <a:prstGeom xmlns:a="http://schemas.openxmlformats.org/drawingml/2006/main" prst="rect">
             <a:avLst/>
@@ -3623,8 +3722,8 @@
         <p:txBody>
           <a:bodyPr xmlns:a="http://schemas.openxmlformats.org/drawingml/2006/main"/>
           <a:lstStyle xmlns:a="http://schemas.openxmlformats.org/drawingml/2006/main">
-            <a:defPPr>
-              <a:defRPr sz="2850" b="1">
+            <a:defPPr algn="l">
+              <a:defRPr sz="3150" b="1">
                 <a:solidFill>
                   <a:srgbClr val="4D6A58"/>
                 </a:solidFill>
@@ -3635,8 +3734,9 @@
             </a:defPPr>
           </a:lstStyle>
           <a:p xmlns:a="http://schemas.openxmlformats.org/drawingml/2006/main">
-            <a:pPr>
-              <a:defRPr sz="2850" b="1">
+            <a:pPr algn="l">
+              <a:buNone/>
+              <a:defRPr sz="3150" b="1">
                 <a:solidFill>
                   <a:srgbClr val="4D6A58"/>
                 </a:solidFill>
@@ -3646,7 +3746,7 @@
               </a:defRPr>
             </a:pPr>
             <a:r>
-              <a:rPr sz="2850" b="1">
+              <a:rPr sz="3150" b="1">
                 <a:solidFill>
                   <a:srgbClr val="4D6A58"/>
                 </a:solidFill>
@@ -3664,7 +3764,7 @@
           <p:cNvPr id="4" name="">
             <a:extLst xmlns:a="http://schemas.openxmlformats.org/drawingml/2006/main">
               <a:ext uri="{FF2B5EF4-FFF2-40B4-BE49-F238E27FC236}">
-                <a16:creationId xmlns:a16="http://schemas.microsoft.com/office/drawing/2014/main" id="{BE9A4090-A495-4A97-8163-0F7A21A507F8}"/>
+                <a16:creationId xmlns:a16="http://schemas.microsoft.com/office/drawing/2014/main" id="{FF33DD9A-D27F-4B71-9475-3CED464D2772}"/>
               </a:ext>
             </a:extLst>
           </p:cNvPr>
@@ -3675,8 +3775,8 @@
         </p:nvSpPr>
         <p:spPr>
           <a:xfrm xmlns:a="http://schemas.openxmlformats.org/drawingml/2006/main">
-            <a:off x="685800" y="2952750"/>
-            <a:ext cx="10096500" cy="1285875"/>
+            <a:off x="685800" y="3009900"/>
+            <a:ext cx="10001250" cy="1381125"/>
           </a:xfrm>
           <a:prstGeom xmlns:a="http://schemas.openxmlformats.org/drawingml/2006/main" prst="rect">
             <a:avLst/>
@@ -3689,7 +3789,7 @@
         <p:txBody>
           <a:bodyPr xmlns:a="http://schemas.openxmlformats.org/drawingml/2006/main"/>
           <a:lstStyle xmlns:a="http://schemas.openxmlformats.org/drawingml/2006/main">
-            <a:defPPr>
+            <a:defPPr algn="l">
               <a:defRPr sz="2250" b="0">
                 <a:solidFill>
                   <a:srgbClr val="213C31"/>
@@ -3701,7 +3801,8 @@
             </a:defPPr>
           </a:lstStyle>
           <a:p xmlns:a="http://schemas.openxmlformats.org/drawingml/2006/main">
-            <a:pPr>
+            <a:pPr algn="l">
+              <a:buNone/>
               <a:defRPr sz="2250" b="0">
                 <a:solidFill>
                   <a:srgbClr val="213C31"/>
@@ -3730,7 +3831,7 @@
           <p:cNvPr id="5" name="">
             <a:extLst xmlns:a="http://schemas.openxmlformats.org/drawingml/2006/main">
               <a:ext uri="{FF2B5EF4-FFF2-40B4-BE49-F238E27FC236}">
-                <a16:creationId xmlns:a16="http://schemas.microsoft.com/office/drawing/2014/main" id="{E1B96E4B-9C13-4BEC-848E-74395C44C1C1}"/>
+                <a16:creationId xmlns:a16="http://schemas.microsoft.com/office/drawing/2014/main" id="{ACB3D251-A0D8-4E1D-ACCC-748E2F480C34}"/>
               </a:ext>
             </a:extLst>
           </p:cNvPr>
@@ -3741,8 +3842,8 @@
         </p:nvSpPr>
         <p:spPr>
           <a:xfrm xmlns:a="http://schemas.openxmlformats.org/drawingml/2006/main">
-            <a:off x="685800" y="4667250"/>
-            <a:ext cx="10096500" cy="1285875"/>
+            <a:off x="685800" y="4819650"/>
+            <a:ext cx="10001250" cy="1190625"/>
           </a:xfrm>
           <a:prstGeom xmlns:a="http://schemas.openxmlformats.org/drawingml/2006/main" prst="rect">
             <a:avLst/>
@@ -3755,7 +3856,7 @@
         <p:txBody>
           <a:bodyPr xmlns:a="http://schemas.openxmlformats.org/drawingml/2006/main"/>
           <a:lstStyle xmlns:a="http://schemas.openxmlformats.org/drawingml/2006/main">
-            <a:defPPr>
+            <a:defPPr algn="l">
               <a:defRPr sz="2175" b="0">
                 <a:solidFill>
                   <a:srgbClr val="55645B"/>
@@ -3767,7 +3868,8 @@
             </a:defPPr>
           </a:lstStyle>
           <a:p xmlns:a="http://schemas.openxmlformats.org/drawingml/2006/main">
-            <a:pPr>
+            <a:pPr algn="l">
+              <a:buNone/>
               <a:defRPr sz="2175" b="0">
                 <a:solidFill>
                   <a:srgbClr val="55645B"/>
@@ -3794,7 +3896,7 @@
     </p:spTree>
     <p:extLst>
       <p:ext uri="{BB962C8B-B14F-4D97-AF65-F5344CB8AC3E}">
-        <p14:creationId xmlns:p14="http://schemas.microsoft.com/office/powerpoint/2010/main" val="1000020031"/>
+        <p14:creationId xmlns:p14="http://schemas.microsoft.com/office/powerpoint/2010/main" val="1715697663"/>
       </p:ext>
     </p:extLst>
   </p:cSld>
@@ -3825,7 +3927,7 @@
           <p:cNvPr id="11" name="">
             <a:extLst xmlns:a="http://schemas.openxmlformats.org/drawingml/2006/main">
               <a:ext uri="{FF2B5EF4-FFF2-40B4-BE49-F238E27FC236}">
-                <a16:creationId xmlns:a16="http://schemas.microsoft.com/office/drawing/2014/main" id="{8B06B01B-D9DB-4375-8A18-81C4454044EF}"/>
+                <a16:creationId xmlns:a16="http://schemas.microsoft.com/office/drawing/2014/main" id="{0F096468-12DF-4E1C-9ECE-5099A867BF93}"/>
               </a:ext>
             </a:extLst>
           </p:cNvPr>
@@ -3850,8 +3952,8 @@
         <p:txBody>
           <a:bodyPr xmlns:a="http://schemas.openxmlformats.org/drawingml/2006/main"/>
           <a:lstStyle xmlns:a="http://schemas.openxmlformats.org/drawingml/2006/main">
-            <a:defPPr>
-              <a:defRPr sz="3225" b="1">
+            <a:defPPr algn="l">
+              <a:defRPr sz="3300" b="1">
                 <a:solidFill>
                   <a:srgbClr val="213C31"/>
                 </a:solidFill>
@@ -3862,8 +3964,9 @@
             </a:defPPr>
           </a:lstStyle>
           <a:p xmlns:a="http://schemas.openxmlformats.org/drawingml/2006/main">
-            <a:pPr>
-              <a:defRPr sz="3225" b="1">
+            <a:pPr algn="l">
+              <a:buNone/>
+              <a:defRPr sz="3300" b="1">
                 <a:solidFill>
                   <a:srgbClr val="213C31"/>
                 </a:solidFill>
@@ -3873,7 +3976,7 @@
               </a:defRPr>
             </a:pPr>
             <a:r>
-              <a:rPr sz="3225" b="1">
+              <a:rPr sz="3300" b="1">
                 <a:solidFill>
                   <a:srgbClr val="213C31"/>
                 </a:solidFill>
@@ -3891,7 +3994,7 @@
           <p:cNvPr id="2" name="">
             <a:extLst xmlns:a="http://schemas.openxmlformats.org/drawingml/2006/main">
               <a:ext uri="{FF2B5EF4-FFF2-40B4-BE49-F238E27FC236}">
-                <a16:creationId xmlns:a16="http://schemas.microsoft.com/office/drawing/2014/main" id="{DBE9A356-4741-46BF-AFFD-281713C040CC}"/>
+                <a16:creationId xmlns:a16="http://schemas.microsoft.com/office/drawing/2014/main" id="{2705BC6D-DC9C-4205-8293-C8E1D4F33CD8}"/>
               </a:ext>
             </a:extLst>
           </p:cNvPr>
@@ -3929,6 +4032,7 @@
           </a:lstStyle>
           <a:p xmlns:a="http://schemas.openxmlformats.org/drawingml/2006/main">
             <a:pPr>
+              <a:buNone/>
               <a:defRPr sz="1350" b="0">
                 <a:solidFill>
                   <a:srgbClr val="55645B"/>
@@ -3957,7 +4061,7 @@
           <p:cNvPr id="3" name="">
             <a:extLst xmlns:a="http://schemas.openxmlformats.org/drawingml/2006/main">
               <a:ext uri="{FF2B5EF4-FFF2-40B4-BE49-F238E27FC236}">
-                <a16:creationId xmlns:a16="http://schemas.microsoft.com/office/drawing/2014/main" id="{E7531101-0608-4617-AA1A-F10FC6C08397}"/>
+                <a16:creationId xmlns:a16="http://schemas.microsoft.com/office/drawing/2014/main" id="{E34367FD-C232-4E79-8B63-FD5DC7D9542F}"/>
               </a:ext>
             </a:extLst>
           </p:cNvPr>
@@ -3968,8 +4072,8 @@
         </p:nvSpPr>
         <p:spPr>
           <a:xfrm xmlns:a="http://schemas.openxmlformats.org/drawingml/2006/main">
-            <a:off x="685800" y="1762125"/>
-            <a:ext cx="10477500" cy="857250"/>
+            <a:off x="685800" y="1743075"/>
+            <a:ext cx="10572750" cy="666750"/>
           </a:xfrm>
           <a:prstGeom xmlns:a="http://schemas.openxmlformats.org/drawingml/2006/main" prst="rect">
             <a:avLst/>
@@ -3982,8 +4086,8 @@
         <p:txBody>
           <a:bodyPr xmlns:a="http://schemas.openxmlformats.org/drawingml/2006/main"/>
           <a:lstStyle xmlns:a="http://schemas.openxmlformats.org/drawingml/2006/main">
-            <a:defPPr>
-              <a:defRPr sz="2850" b="1">
+            <a:defPPr algn="l">
+              <a:defRPr sz="2700" b="1">
                 <a:solidFill>
                   <a:srgbClr val="4D6A58"/>
                 </a:solidFill>
@@ -3994,8 +4098,9 @@
             </a:defPPr>
           </a:lstStyle>
           <a:p xmlns:a="http://schemas.openxmlformats.org/drawingml/2006/main">
-            <a:pPr>
-              <a:defRPr sz="2850" b="1">
+            <a:pPr algn="l">
+              <a:buNone/>
+              <a:defRPr sz="2700" b="1">
                 <a:solidFill>
                   <a:srgbClr val="4D6A58"/>
                 </a:solidFill>
@@ -4005,7 +4110,7 @@
               </a:defRPr>
             </a:pPr>
             <a:r>
-              <a:rPr sz="2850" b="1">
+              <a:rPr sz="2700" b="1">
                 <a:solidFill>
                   <a:srgbClr val="4D6A58"/>
                 </a:solidFill>
@@ -4023,7 +4128,7 @@
           <p:cNvPr id="4" name="">
             <a:extLst xmlns:a="http://schemas.openxmlformats.org/drawingml/2006/main">
               <a:ext uri="{FF2B5EF4-FFF2-40B4-BE49-F238E27FC236}">
-                <a16:creationId xmlns:a16="http://schemas.microsoft.com/office/drawing/2014/main" id="{DE1A0A44-CF50-4F7C-8BD7-E1EE04C86478}"/>
+                <a16:creationId xmlns:a16="http://schemas.microsoft.com/office/drawing/2014/main" id="{A1293F79-680E-42A9-9B68-546E9FCD66B7}"/>
               </a:ext>
             </a:extLst>
           </p:cNvPr>
@@ -4035,7 +4140,7 @@
         <p:spPr>
           <a:xfrm xmlns:a="http://schemas.openxmlformats.org/drawingml/2006/main">
             <a:off x="685800" y="2809875"/>
-            <a:ext cx="3524250" cy="809625"/>
+            <a:ext cx="4572000" cy="666750"/>
           </a:xfrm>
           <a:prstGeom xmlns:a="http://schemas.openxmlformats.org/drawingml/2006/main" prst="rect">
             <a:avLst/>
@@ -4048,8 +4153,8 @@
         <p:txBody>
           <a:bodyPr xmlns:a="http://schemas.openxmlformats.org/drawingml/2006/main"/>
           <a:lstStyle xmlns:a="http://schemas.openxmlformats.org/drawingml/2006/main">
-            <a:defPPr>
-              <a:defRPr sz="2025" b="1">
+            <a:defPPr algn="l">
+              <a:defRPr sz="2100" b="1">
                 <a:solidFill>
                   <a:srgbClr val="4D6A58"/>
                 </a:solidFill>
@@ -4060,8 +4165,9 @@
             </a:defPPr>
           </a:lstStyle>
           <a:p xmlns:a="http://schemas.openxmlformats.org/drawingml/2006/main">
-            <a:pPr>
-              <a:defRPr sz="2025" b="1">
+            <a:pPr algn="l">
+              <a:buNone/>
+              <a:defRPr sz="2100" b="1">
                 <a:solidFill>
                   <a:srgbClr val="4D6A58"/>
                 </a:solidFill>
@@ -4071,7 +4177,7 @@
               </a:defRPr>
             </a:pPr>
             <a:r>
-              <a:rPr sz="2025" b="1">
+              <a:rPr sz="2100" b="1">
                 <a:solidFill>
                   <a:srgbClr val="4D6A58"/>
                 </a:solidFill>
@@ -4089,7 +4195,7 @@
           <p:cNvPr id="5" name="">
             <a:extLst xmlns:a="http://schemas.openxmlformats.org/drawingml/2006/main">
               <a:ext uri="{FF2B5EF4-FFF2-40B4-BE49-F238E27FC236}">
-                <a16:creationId xmlns:a16="http://schemas.microsoft.com/office/drawing/2014/main" id="{5EAE6C1C-7247-4122-8906-15AA62AFE61C}"/>
+                <a16:creationId xmlns:a16="http://schemas.microsoft.com/office/drawing/2014/main" id="{4AD71EAC-E20D-4301-B07A-8729594A8CA8}"/>
               </a:ext>
             </a:extLst>
           </p:cNvPr>
@@ -4100,8 +4206,8 @@
         </p:nvSpPr>
         <p:spPr>
           <a:xfrm xmlns:a="http://schemas.openxmlformats.org/drawingml/2006/main">
-            <a:off x="4667250" y="2809875"/>
-            <a:ext cx="6762750" cy="809625"/>
+            <a:off x="5619750" y="2809875"/>
+            <a:ext cx="5810250" cy="762000"/>
           </a:xfrm>
           <a:prstGeom xmlns:a="http://schemas.openxmlformats.org/drawingml/2006/main" prst="rect">
             <a:avLst/>
@@ -4114,8 +4220,8 @@
         <p:txBody>
           <a:bodyPr xmlns:a="http://schemas.openxmlformats.org/drawingml/2006/main"/>
           <a:lstStyle xmlns:a="http://schemas.openxmlformats.org/drawingml/2006/main">
-            <a:defPPr>
-              <a:defRPr sz="2025" b="0">
+            <a:defPPr algn="l">
+              <a:defRPr sz="2100" b="0">
                 <a:solidFill>
                   <a:srgbClr val="213C31"/>
                 </a:solidFill>
@@ -4126,8 +4232,9 @@
             </a:defPPr>
           </a:lstStyle>
           <a:p xmlns:a="http://schemas.openxmlformats.org/drawingml/2006/main">
-            <a:pPr>
-              <a:defRPr sz="2025" b="0">
+            <a:pPr algn="l">
+              <a:buNone/>
+              <a:defRPr sz="2100" b="0">
                 <a:solidFill>
                   <a:srgbClr val="213C31"/>
                 </a:solidFill>
@@ -4137,7 +4244,7 @@
               </a:defRPr>
             </a:pPr>
             <a:r>
-              <a:rPr sz="2025" b="0">
+              <a:rPr sz="2100" b="0">
                 <a:solidFill>
                   <a:srgbClr val="213C31"/>
                 </a:solidFill>
@@ -4155,7 +4262,7 @@
           <p:cNvPr id="6" name="">
             <a:extLst xmlns:a="http://schemas.openxmlformats.org/drawingml/2006/main">
               <a:ext uri="{FF2B5EF4-FFF2-40B4-BE49-F238E27FC236}">
-                <a16:creationId xmlns:a16="http://schemas.microsoft.com/office/drawing/2014/main" id="{B7F33575-DD25-431A-881B-28C737DEBC70}"/>
+                <a16:creationId xmlns:a16="http://schemas.microsoft.com/office/drawing/2014/main" id="{9FC9C3EA-38B2-4B37-B9E1-4A06C2506F1E}"/>
               </a:ext>
             </a:extLst>
           </p:cNvPr>
@@ -4166,8 +4273,8 @@
         </p:nvSpPr>
         <p:spPr>
           <a:xfrm xmlns:a="http://schemas.openxmlformats.org/drawingml/2006/main">
-            <a:off x="685800" y="3762375"/>
-            <a:ext cx="3524250" cy="809625"/>
+            <a:off x="685800" y="3714750"/>
+            <a:ext cx="4572000" cy="666750"/>
           </a:xfrm>
           <a:prstGeom xmlns:a="http://schemas.openxmlformats.org/drawingml/2006/main" prst="rect">
             <a:avLst/>
@@ -4180,8 +4287,8 @@
         <p:txBody>
           <a:bodyPr xmlns:a="http://schemas.openxmlformats.org/drawingml/2006/main"/>
           <a:lstStyle xmlns:a="http://schemas.openxmlformats.org/drawingml/2006/main">
-            <a:defPPr>
-              <a:defRPr sz="2025" b="1">
+            <a:defPPr algn="l">
+              <a:defRPr sz="2100" b="1">
                 <a:solidFill>
                   <a:srgbClr val="4D6A58"/>
                 </a:solidFill>
@@ -4192,8 +4299,9 @@
             </a:defPPr>
           </a:lstStyle>
           <a:p xmlns:a="http://schemas.openxmlformats.org/drawingml/2006/main">
-            <a:pPr>
-              <a:defRPr sz="2025" b="1">
+            <a:pPr algn="l">
+              <a:buNone/>
+              <a:defRPr sz="2100" b="1">
                 <a:solidFill>
                   <a:srgbClr val="4D6A58"/>
                 </a:solidFill>
@@ -4203,7 +4311,7 @@
               </a:defRPr>
             </a:pPr>
             <a:r>
-              <a:rPr sz="2025" b="1">
+              <a:rPr sz="2100" b="1">
                 <a:solidFill>
                   <a:srgbClr val="4D6A58"/>
                 </a:solidFill>
@@ -4221,7 +4329,7 @@
           <p:cNvPr id="7" name="">
             <a:extLst xmlns:a="http://schemas.openxmlformats.org/drawingml/2006/main">
               <a:ext uri="{FF2B5EF4-FFF2-40B4-BE49-F238E27FC236}">
-                <a16:creationId xmlns:a16="http://schemas.microsoft.com/office/drawing/2014/main" id="{C8499ED3-3D31-4194-ACF1-45470EA3CC7E}"/>
+                <a16:creationId xmlns:a16="http://schemas.microsoft.com/office/drawing/2014/main" id="{2F261F24-19E6-4773-90D0-80CCFFD82B3B}"/>
               </a:ext>
             </a:extLst>
           </p:cNvPr>
@@ -4232,8 +4340,8 @@
         </p:nvSpPr>
         <p:spPr>
           <a:xfrm xmlns:a="http://schemas.openxmlformats.org/drawingml/2006/main">
-            <a:off x="4667250" y="3762375"/>
-            <a:ext cx="6762750" cy="809625"/>
+            <a:off x="5619750" y="3714750"/>
+            <a:ext cx="5810250" cy="762000"/>
           </a:xfrm>
           <a:prstGeom xmlns:a="http://schemas.openxmlformats.org/drawingml/2006/main" prst="rect">
             <a:avLst/>
@@ -4246,8 +4354,8 @@
         <p:txBody>
           <a:bodyPr xmlns:a="http://schemas.openxmlformats.org/drawingml/2006/main"/>
           <a:lstStyle xmlns:a="http://schemas.openxmlformats.org/drawingml/2006/main">
-            <a:defPPr>
-              <a:defRPr sz="2025" b="0">
+            <a:defPPr algn="l">
+              <a:defRPr sz="2100" b="0">
                 <a:solidFill>
                   <a:srgbClr val="213C31"/>
                 </a:solidFill>
@@ -4258,8 +4366,9 @@
             </a:defPPr>
           </a:lstStyle>
           <a:p xmlns:a="http://schemas.openxmlformats.org/drawingml/2006/main">
-            <a:pPr>
-              <a:defRPr sz="2025" b="0">
+            <a:pPr algn="l">
+              <a:buNone/>
+              <a:defRPr sz="2100" b="0">
                 <a:solidFill>
                   <a:srgbClr val="213C31"/>
                 </a:solidFill>
@@ -4269,7 +4378,7 @@
               </a:defRPr>
             </a:pPr>
             <a:r>
-              <a:rPr sz="2025" b="0">
+              <a:rPr sz="2100" b="0">
                 <a:solidFill>
                   <a:srgbClr val="213C31"/>
                 </a:solidFill>
@@ -4287,7 +4396,7 @@
           <p:cNvPr id="8" name="">
             <a:extLst xmlns:a="http://schemas.openxmlformats.org/drawingml/2006/main">
               <a:ext uri="{FF2B5EF4-FFF2-40B4-BE49-F238E27FC236}">
-                <a16:creationId xmlns:a16="http://schemas.microsoft.com/office/drawing/2014/main" id="{617D3CA4-8413-4B6E-8DCF-7D263CF8DFFD}"/>
+                <a16:creationId xmlns:a16="http://schemas.microsoft.com/office/drawing/2014/main" id="{DEFF0FF1-43D1-4F8D-B8E1-521EDE1ED8B3}"/>
               </a:ext>
             </a:extLst>
           </p:cNvPr>
@@ -4298,8 +4407,8 @@
         </p:nvSpPr>
         <p:spPr>
           <a:xfrm xmlns:a="http://schemas.openxmlformats.org/drawingml/2006/main">
-            <a:off x="685800" y="4714875"/>
-            <a:ext cx="3524250" cy="809625"/>
+            <a:off x="685800" y="4619625"/>
+            <a:ext cx="4572000" cy="666750"/>
           </a:xfrm>
           <a:prstGeom xmlns:a="http://schemas.openxmlformats.org/drawingml/2006/main" prst="rect">
             <a:avLst/>
@@ -4312,8 +4421,8 @@
         <p:txBody>
           <a:bodyPr xmlns:a="http://schemas.openxmlformats.org/drawingml/2006/main"/>
           <a:lstStyle xmlns:a="http://schemas.openxmlformats.org/drawingml/2006/main">
-            <a:defPPr>
-              <a:defRPr sz="2025" b="1">
+            <a:defPPr algn="l">
+              <a:defRPr sz="2100" b="1">
                 <a:solidFill>
                   <a:srgbClr val="4D6A58"/>
                 </a:solidFill>
@@ -4324,8 +4433,9 @@
             </a:defPPr>
           </a:lstStyle>
           <a:p xmlns:a="http://schemas.openxmlformats.org/drawingml/2006/main">
-            <a:pPr>
-              <a:defRPr sz="2025" b="1">
+            <a:pPr algn="l">
+              <a:buNone/>
+              <a:defRPr sz="2100" b="1">
                 <a:solidFill>
                   <a:srgbClr val="4D6A58"/>
                 </a:solidFill>
@@ -4335,7 +4445,7 @@
               </a:defRPr>
             </a:pPr>
             <a:r>
-              <a:rPr sz="2025" b="1">
+              <a:rPr sz="2100" b="1">
                 <a:solidFill>
                   <a:srgbClr val="4D6A58"/>
                 </a:solidFill>
@@ -4353,7 +4463,7 @@
           <p:cNvPr id="9" name="">
             <a:extLst xmlns:a="http://schemas.openxmlformats.org/drawingml/2006/main">
               <a:ext uri="{FF2B5EF4-FFF2-40B4-BE49-F238E27FC236}">
-                <a16:creationId xmlns:a16="http://schemas.microsoft.com/office/drawing/2014/main" id="{453E75E7-56D5-46D9-A0AF-E8114475B841}"/>
+                <a16:creationId xmlns:a16="http://schemas.microsoft.com/office/drawing/2014/main" id="{5A096A66-027E-476B-85DD-23B28292D3A2}"/>
               </a:ext>
             </a:extLst>
           </p:cNvPr>
@@ -4364,8 +4474,8 @@
         </p:nvSpPr>
         <p:spPr>
           <a:xfrm xmlns:a="http://schemas.openxmlformats.org/drawingml/2006/main">
-            <a:off x="4667250" y="4714875"/>
-            <a:ext cx="6762750" cy="809625"/>
+            <a:off x="5619750" y="4619625"/>
+            <a:ext cx="5810250" cy="762000"/>
           </a:xfrm>
           <a:prstGeom xmlns:a="http://schemas.openxmlformats.org/drawingml/2006/main" prst="rect">
             <a:avLst/>
@@ -4378,8 +4488,8 @@
         <p:txBody>
           <a:bodyPr xmlns:a="http://schemas.openxmlformats.org/drawingml/2006/main"/>
           <a:lstStyle xmlns:a="http://schemas.openxmlformats.org/drawingml/2006/main">
-            <a:defPPr>
-              <a:defRPr sz="2025" b="0">
+            <a:defPPr algn="l">
+              <a:defRPr sz="2100" b="0">
                 <a:solidFill>
                   <a:srgbClr val="213C31"/>
                 </a:solidFill>
@@ -4390,8 +4500,9 @@
             </a:defPPr>
           </a:lstStyle>
           <a:p xmlns:a="http://schemas.openxmlformats.org/drawingml/2006/main">
-            <a:pPr>
-              <a:defRPr sz="2025" b="0">
+            <a:pPr algn="l">
+              <a:buNone/>
+              <a:defRPr sz="2100" b="0">
                 <a:solidFill>
                   <a:srgbClr val="213C31"/>
                 </a:solidFill>
@@ -4401,7 +4512,7 @@
               </a:defRPr>
             </a:pPr>
             <a:r>
-              <a:rPr sz="2025" b="0">
+              <a:rPr sz="2100" b="0">
                 <a:solidFill>
                   <a:srgbClr val="213C31"/>
                 </a:solidFill>
@@ -4419,7 +4530,7 @@
           <p:cNvPr id="10" name="">
             <a:extLst xmlns:a="http://schemas.openxmlformats.org/drawingml/2006/main">
               <a:ext uri="{FF2B5EF4-FFF2-40B4-BE49-F238E27FC236}">
-                <a16:creationId xmlns:a16="http://schemas.microsoft.com/office/drawing/2014/main" id="{9848F011-3E8F-40E2-A7E4-516C9BA9F8F3}"/>
+                <a16:creationId xmlns:a16="http://schemas.microsoft.com/office/drawing/2014/main" id="{B980390F-9871-4665-9836-0AC8A1D51325}"/>
               </a:ext>
             </a:extLst>
           </p:cNvPr>
@@ -4430,8 +4541,8 @@
         </p:nvSpPr>
         <p:spPr>
           <a:xfrm xmlns:a="http://schemas.openxmlformats.org/drawingml/2006/main">
-            <a:off x="685800" y="5857875"/>
-            <a:ext cx="10477500" cy="381000"/>
+            <a:off x="685800" y="5743575"/>
+            <a:ext cx="10477500" cy="457200"/>
           </a:xfrm>
           <a:prstGeom xmlns:a="http://schemas.openxmlformats.org/drawingml/2006/main" prst="rect">
             <a:avLst/>
@@ -4444,8 +4555,8 @@
         <p:txBody>
           <a:bodyPr xmlns:a="http://schemas.openxmlformats.org/drawingml/2006/main"/>
           <a:lstStyle xmlns:a="http://schemas.openxmlformats.org/drawingml/2006/main">
-            <a:defPPr>
-              <a:defRPr sz="1800" b="0">
+            <a:defPPr algn="l">
+              <a:defRPr sz="1950" b="0">
                 <a:solidFill>
                   <a:srgbClr val="55645B"/>
                 </a:solidFill>
@@ -4456,8 +4567,9 @@
             </a:defPPr>
           </a:lstStyle>
           <a:p xmlns:a="http://schemas.openxmlformats.org/drawingml/2006/main">
-            <a:pPr>
-              <a:defRPr sz="1800" b="0">
+            <a:pPr algn="l">
+              <a:buNone/>
+              <a:defRPr sz="1950" b="0">
                 <a:solidFill>
                   <a:srgbClr val="55645B"/>
                 </a:solidFill>
@@ -4467,7 +4579,7 @@
               </a:defRPr>
             </a:pPr>
             <a:r>
-              <a:rPr sz="1800" b="0">
+              <a:rPr sz="1950" b="0">
                 <a:solidFill>
                   <a:srgbClr val="55645B"/>
                 </a:solidFill>
@@ -4483,7 +4595,7 @@
     </p:spTree>
     <p:extLst>
       <p:ext uri="{BB962C8B-B14F-4D97-AF65-F5344CB8AC3E}">
-        <p14:creationId xmlns:p14="http://schemas.microsoft.com/office/powerpoint/2010/main" val="2107644898"/>
+        <p14:creationId xmlns:p14="http://schemas.microsoft.com/office/powerpoint/2010/main" val="847972443"/>
       </p:ext>
     </p:extLst>
   </p:cSld>
@@ -4514,7 +4626,7 @@
           <p:cNvPr id="11" name="">
             <a:extLst xmlns:a="http://schemas.openxmlformats.org/drawingml/2006/main">
               <a:ext uri="{FF2B5EF4-FFF2-40B4-BE49-F238E27FC236}">
-                <a16:creationId xmlns:a16="http://schemas.microsoft.com/office/drawing/2014/main" id="{13C35B2F-90C0-4800-91A4-972BC5236036}"/>
+                <a16:creationId xmlns:a16="http://schemas.microsoft.com/office/drawing/2014/main" id="{5E1228C6-273E-4B61-88CF-5F289AE68C14}"/>
               </a:ext>
             </a:extLst>
           </p:cNvPr>
@@ -4539,8 +4651,8 @@
         <p:txBody>
           <a:bodyPr xmlns:a="http://schemas.openxmlformats.org/drawingml/2006/main"/>
           <a:lstStyle xmlns:a="http://schemas.openxmlformats.org/drawingml/2006/main">
-            <a:defPPr>
-              <a:defRPr sz="3225" b="1">
+            <a:defPPr algn="l">
+              <a:defRPr sz="3300" b="1">
                 <a:solidFill>
                   <a:srgbClr val="213C31"/>
                 </a:solidFill>
@@ -4551,8 +4663,9 @@
             </a:defPPr>
           </a:lstStyle>
           <a:p xmlns:a="http://schemas.openxmlformats.org/drawingml/2006/main">
-            <a:pPr>
-              <a:defRPr sz="3225" b="1">
+            <a:pPr algn="l">
+              <a:buNone/>
+              <a:defRPr sz="3300" b="1">
                 <a:solidFill>
                   <a:srgbClr val="213C31"/>
                 </a:solidFill>
@@ -4562,7 +4675,7 @@
               </a:defRPr>
             </a:pPr>
             <a:r>
-              <a:rPr sz="3225" b="1">
+              <a:rPr sz="3300" b="1">
                 <a:solidFill>
                   <a:srgbClr val="213C31"/>
                 </a:solidFill>
@@ -4580,7 +4693,7 @@
           <p:cNvPr id="2" name="">
             <a:extLst xmlns:a="http://schemas.openxmlformats.org/drawingml/2006/main">
               <a:ext uri="{FF2B5EF4-FFF2-40B4-BE49-F238E27FC236}">
-                <a16:creationId xmlns:a16="http://schemas.microsoft.com/office/drawing/2014/main" id="{2E92648C-3181-4BF3-9916-941876235FBF}"/>
+                <a16:creationId xmlns:a16="http://schemas.microsoft.com/office/drawing/2014/main" id="{EBE84F37-3A6D-471E-AF97-1EF40D13E77E}"/>
               </a:ext>
             </a:extLst>
           </p:cNvPr>
@@ -4618,6 +4731,7 @@
           </a:lstStyle>
           <a:p xmlns:a="http://schemas.openxmlformats.org/drawingml/2006/main">
             <a:pPr>
+              <a:buNone/>
               <a:defRPr sz="1350" b="0">
                 <a:solidFill>
                   <a:srgbClr val="55645B"/>
@@ -4646,7 +4760,7 @@
           <p:cNvPr id="3" name="">
             <a:extLst xmlns:a="http://schemas.openxmlformats.org/drawingml/2006/main">
               <a:ext uri="{FF2B5EF4-FFF2-40B4-BE49-F238E27FC236}">
-                <a16:creationId xmlns:a16="http://schemas.microsoft.com/office/drawing/2014/main" id="{A275F8A5-4FED-400F-AB00-F16C0EBAA8D3}"/>
+                <a16:creationId xmlns:a16="http://schemas.microsoft.com/office/drawing/2014/main" id="{F0840C1C-E2D8-43D9-BCFB-96F98CF15DBB}"/>
               </a:ext>
             </a:extLst>
           </p:cNvPr>
@@ -4657,8 +4771,8 @@
         </p:nvSpPr>
         <p:spPr>
           <a:xfrm xmlns:a="http://schemas.openxmlformats.org/drawingml/2006/main">
-            <a:off x="685800" y="1762125"/>
-            <a:ext cx="3524250" cy="809625"/>
+            <a:off x="685800" y="1809750"/>
+            <a:ext cx="3714750" cy="742950"/>
           </a:xfrm>
           <a:prstGeom xmlns:a="http://schemas.openxmlformats.org/drawingml/2006/main" prst="rect">
             <a:avLst/>
@@ -4671,8 +4785,8 @@
         <p:txBody>
           <a:bodyPr xmlns:a="http://schemas.openxmlformats.org/drawingml/2006/main"/>
           <a:lstStyle xmlns:a="http://schemas.openxmlformats.org/drawingml/2006/main">
-            <a:defPPr>
-              <a:defRPr sz="2025" b="1">
+            <a:defPPr algn="l">
+              <a:defRPr sz="2100" b="1">
                 <a:solidFill>
                   <a:srgbClr val="4D6A58"/>
                 </a:solidFill>
@@ -4683,8 +4797,9 @@
             </a:defPPr>
           </a:lstStyle>
           <a:p xmlns:a="http://schemas.openxmlformats.org/drawingml/2006/main">
-            <a:pPr>
-              <a:defRPr sz="2025" b="1">
+            <a:pPr algn="l">
+              <a:buNone/>
+              <a:defRPr sz="2100" b="1">
                 <a:solidFill>
                   <a:srgbClr val="4D6A58"/>
                 </a:solidFill>
@@ -4694,7 +4809,7 @@
               </a:defRPr>
             </a:pPr>
             <a:r>
-              <a:rPr sz="2025" b="1">
+              <a:rPr sz="2100" b="1">
                 <a:solidFill>
                   <a:srgbClr val="4D6A58"/>
                 </a:solidFill>
@@ -4712,7 +4827,7 @@
           <p:cNvPr id="4" name="">
             <a:extLst xmlns:a="http://schemas.openxmlformats.org/drawingml/2006/main">
               <a:ext uri="{FF2B5EF4-FFF2-40B4-BE49-F238E27FC236}">
-                <a16:creationId xmlns:a16="http://schemas.microsoft.com/office/drawing/2014/main" id="{9AE1DFB4-BA7C-4D55-A4AC-50377D5BB242}"/>
+                <a16:creationId xmlns:a16="http://schemas.microsoft.com/office/drawing/2014/main" id="{495E6568-27A1-49C1-97EB-D4A11EBA4203}"/>
               </a:ext>
             </a:extLst>
           </p:cNvPr>
@@ -4723,8 +4838,8 @@
         </p:nvSpPr>
         <p:spPr>
           <a:xfrm xmlns:a="http://schemas.openxmlformats.org/drawingml/2006/main">
-            <a:off x="4667250" y="1762125"/>
-            <a:ext cx="6762750" cy="809625"/>
+            <a:off x="4953000" y="1809750"/>
+            <a:ext cx="6429375" cy="857250"/>
           </a:xfrm>
           <a:prstGeom xmlns:a="http://schemas.openxmlformats.org/drawingml/2006/main" prst="rect">
             <a:avLst/>
@@ -4737,8 +4852,8 @@
         <p:txBody>
           <a:bodyPr xmlns:a="http://schemas.openxmlformats.org/drawingml/2006/main"/>
           <a:lstStyle xmlns:a="http://schemas.openxmlformats.org/drawingml/2006/main">
-            <a:defPPr>
-              <a:defRPr sz="2025" b="0">
+            <a:defPPr algn="l">
+              <a:defRPr sz="2100" b="0">
                 <a:solidFill>
                   <a:srgbClr val="213C31"/>
                 </a:solidFill>
@@ -4749,8 +4864,9 @@
             </a:defPPr>
           </a:lstStyle>
           <a:p xmlns:a="http://schemas.openxmlformats.org/drawingml/2006/main">
-            <a:pPr>
-              <a:defRPr sz="2025" b="0">
+            <a:pPr algn="l">
+              <a:buNone/>
+              <a:defRPr sz="2100" b="0">
                 <a:solidFill>
                   <a:srgbClr val="213C31"/>
                 </a:solidFill>
@@ -4760,7 +4876,7 @@
               </a:defRPr>
             </a:pPr>
             <a:r>
-              <a:rPr sz="2025" b="0">
+              <a:rPr sz="2100" b="0">
                 <a:solidFill>
                   <a:srgbClr val="213C31"/>
                 </a:solidFill>
@@ -4778,7 +4894,7 @@
           <p:cNvPr id="5" name="">
             <a:extLst xmlns:a="http://schemas.openxmlformats.org/drawingml/2006/main">
               <a:ext uri="{FF2B5EF4-FFF2-40B4-BE49-F238E27FC236}">
-                <a16:creationId xmlns:a16="http://schemas.microsoft.com/office/drawing/2014/main" id="{5A8DC436-4593-4BB9-A37C-0963EA25C1E9}"/>
+                <a16:creationId xmlns:a16="http://schemas.microsoft.com/office/drawing/2014/main" id="{EE3423F5-ED76-4E00-BA18-90B84EEA0D00}"/>
               </a:ext>
             </a:extLst>
           </p:cNvPr>
@@ -4789,8 +4905,8 @@
         </p:nvSpPr>
         <p:spPr>
           <a:xfrm xmlns:a="http://schemas.openxmlformats.org/drawingml/2006/main">
-            <a:off x="685800" y="2714625"/>
-            <a:ext cx="3524250" cy="809625"/>
+            <a:off x="685800" y="2800350"/>
+            <a:ext cx="3714750" cy="742950"/>
           </a:xfrm>
           <a:prstGeom xmlns:a="http://schemas.openxmlformats.org/drawingml/2006/main" prst="rect">
             <a:avLst/>
@@ -4803,8 +4919,8 @@
         <p:txBody>
           <a:bodyPr xmlns:a="http://schemas.openxmlformats.org/drawingml/2006/main"/>
           <a:lstStyle xmlns:a="http://schemas.openxmlformats.org/drawingml/2006/main">
-            <a:defPPr>
-              <a:defRPr sz="2025" b="1">
+            <a:defPPr algn="l">
+              <a:defRPr sz="2100" b="1">
                 <a:solidFill>
                   <a:srgbClr val="4D6A58"/>
                 </a:solidFill>
@@ -4815,8 +4931,9 @@
             </a:defPPr>
           </a:lstStyle>
           <a:p xmlns:a="http://schemas.openxmlformats.org/drawingml/2006/main">
-            <a:pPr>
-              <a:defRPr sz="2025" b="1">
+            <a:pPr algn="l">
+              <a:buNone/>
+              <a:defRPr sz="2100" b="1">
                 <a:solidFill>
                   <a:srgbClr val="4D6A58"/>
                 </a:solidFill>
@@ -4826,7 +4943,7 @@
               </a:defRPr>
             </a:pPr>
             <a:r>
-              <a:rPr sz="2025" b="1">
+              <a:rPr sz="2100" b="1">
                 <a:solidFill>
                   <a:srgbClr val="4D6A58"/>
                 </a:solidFill>
@@ -4844,7 +4961,7 @@
           <p:cNvPr id="6" name="">
             <a:extLst xmlns:a="http://schemas.openxmlformats.org/drawingml/2006/main">
               <a:ext uri="{FF2B5EF4-FFF2-40B4-BE49-F238E27FC236}">
-                <a16:creationId xmlns:a16="http://schemas.microsoft.com/office/drawing/2014/main" id="{B4F71E62-8097-48A5-B79E-856535776F64}"/>
+                <a16:creationId xmlns:a16="http://schemas.microsoft.com/office/drawing/2014/main" id="{293DA360-C05E-4419-95BF-72D58055BBC6}"/>
               </a:ext>
             </a:extLst>
           </p:cNvPr>
@@ -4855,8 +4972,8 @@
         </p:nvSpPr>
         <p:spPr>
           <a:xfrm xmlns:a="http://schemas.openxmlformats.org/drawingml/2006/main">
-            <a:off x="4667250" y="2714625"/>
-            <a:ext cx="6762750" cy="809625"/>
+            <a:off x="4953000" y="2800350"/>
+            <a:ext cx="6429375" cy="857250"/>
           </a:xfrm>
           <a:prstGeom xmlns:a="http://schemas.openxmlformats.org/drawingml/2006/main" prst="rect">
             <a:avLst/>
@@ -4869,8 +4986,8 @@
         <p:txBody>
           <a:bodyPr xmlns:a="http://schemas.openxmlformats.org/drawingml/2006/main"/>
           <a:lstStyle xmlns:a="http://schemas.openxmlformats.org/drawingml/2006/main">
-            <a:defPPr>
-              <a:defRPr sz="2025" b="0">
+            <a:defPPr algn="l">
+              <a:defRPr sz="2100" b="0">
                 <a:solidFill>
                   <a:srgbClr val="213C31"/>
                 </a:solidFill>
@@ -4881,8 +4998,9 @@
             </a:defPPr>
           </a:lstStyle>
           <a:p xmlns:a="http://schemas.openxmlformats.org/drawingml/2006/main">
-            <a:pPr>
-              <a:defRPr sz="2025" b="0">
+            <a:pPr algn="l">
+              <a:buNone/>
+              <a:defRPr sz="2100" b="0">
                 <a:solidFill>
                   <a:srgbClr val="213C31"/>
                 </a:solidFill>
@@ -4892,7 +5010,7 @@
               </a:defRPr>
             </a:pPr>
             <a:r>
-              <a:rPr sz="2025" b="0">
+              <a:rPr sz="2100" b="0">
                 <a:solidFill>
                   <a:srgbClr val="213C31"/>
                 </a:solidFill>
@@ -4910,7 +5028,7 @@
           <p:cNvPr id="7" name="">
             <a:extLst xmlns:a="http://schemas.openxmlformats.org/drawingml/2006/main">
               <a:ext uri="{FF2B5EF4-FFF2-40B4-BE49-F238E27FC236}">
-                <a16:creationId xmlns:a16="http://schemas.microsoft.com/office/drawing/2014/main" id="{A3A8BD7D-09B7-4972-9B5F-7C7B9A54D7DC}"/>
+                <a16:creationId xmlns:a16="http://schemas.microsoft.com/office/drawing/2014/main" id="{3F49211B-C72B-4C6E-9E86-DEC57EFF1B2B}"/>
               </a:ext>
             </a:extLst>
           </p:cNvPr>
@@ -4921,8 +5039,8 @@
         </p:nvSpPr>
         <p:spPr>
           <a:xfrm xmlns:a="http://schemas.openxmlformats.org/drawingml/2006/main">
-            <a:off x="685800" y="3667125"/>
-            <a:ext cx="3524250" cy="809625"/>
+            <a:off x="685800" y="3790950"/>
+            <a:ext cx="3714750" cy="742950"/>
           </a:xfrm>
           <a:prstGeom xmlns:a="http://schemas.openxmlformats.org/drawingml/2006/main" prst="rect">
             <a:avLst/>
@@ -4935,8 +5053,8 @@
         <p:txBody>
           <a:bodyPr xmlns:a="http://schemas.openxmlformats.org/drawingml/2006/main"/>
           <a:lstStyle xmlns:a="http://schemas.openxmlformats.org/drawingml/2006/main">
-            <a:defPPr>
-              <a:defRPr sz="2025" b="1">
+            <a:defPPr algn="l">
+              <a:defRPr sz="2100" b="1">
                 <a:solidFill>
                   <a:srgbClr val="4D6A58"/>
                 </a:solidFill>
@@ -4947,8 +5065,9 @@
             </a:defPPr>
           </a:lstStyle>
           <a:p xmlns:a="http://schemas.openxmlformats.org/drawingml/2006/main">
-            <a:pPr>
-              <a:defRPr sz="2025" b="1">
+            <a:pPr algn="l">
+              <a:buNone/>
+              <a:defRPr sz="2100" b="1">
                 <a:solidFill>
                   <a:srgbClr val="4D6A58"/>
                 </a:solidFill>
@@ -4958,7 +5077,7 @@
               </a:defRPr>
             </a:pPr>
             <a:r>
-              <a:rPr sz="2025" b="1">
+              <a:rPr sz="2100" b="1">
                 <a:solidFill>
                   <a:srgbClr val="4D6A58"/>
                 </a:solidFill>
@@ -4976,7 +5095,7 @@
           <p:cNvPr id="8" name="">
             <a:extLst xmlns:a="http://schemas.openxmlformats.org/drawingml/2006/main">
               <a:ext uri="{FF2B5EF4-FFF2-40B4-BE49-F238E27FC236}">
-                <a16:creationId xmlns:a16="http://schemas.microsoft.com/office/drawing/2014/main" id="{F66E711A-0E47-4CF6-A129-A1B77E2BE8C9}"/>
+                <a16:creationId xmlns:a16="http://schemas.microsoft.com/office/drawing/2014/main" id="{FE3C6ADD-3C6D-45C5-B397-B2659DAD9B1B}"/>
               </a:ext>
             </a:extLst>
           </p:cNvPr>
@@ -4987,8 +5106,8 @@
         </p:nvSpPr>
         <p:spPr>
           <a:xfrm xmlns:a="http://schemas.openxmlformats.org/drawingml/2006/main">
-            <a:off x="4667250" y="3667125"/>
-            <a:ext cx="6762750" cy="809625"/>
+            <a:off x="4953000" y="3790950"/>
+            <a:ext cx="6429375" cy="857250"/>
           </a:xfrm>
           <a:prstGeom xmlns:a="http://schemas.openxmlformats.org/drawingml/2006/main" prst="rect">
             <a:avLst/>
@@ -5001,8 +5120,8 @@
         <p:txBody>
           <a:bodyPr xmlns:a="http://schemas.openxmlformats.org/drawingml/2006/main"/>
           <a:lstStyle xmlns:a="http://schemas.openxmlformats.org/drawingml/2006/main">
-            <a:defPPr>
-              <a:defRPr sz="2025" b="0">
+            <a:defPPr algn="l">
+              <a:defRPr sz="2100" b="0">
                 <a:solidFill>
                   <a:srgbClr val="213C31"/>
                 </a:solidFill>
@@ -5013,8 +5132,9 @@
             </a:defPPr>
           </a:lstStyle>
           <a:p xmlns:a="http://schemas.openxmlformats.org/drawingml/2006/main">
-            <a:pPr>
-              <a:defRPr sz="2025" b="0">
+            <a:pPr algn="l">
+              <a:buNone/>
+              <a:defRPr sz="2100" b="0">
                 <a:solidFill>
                   <a:srgbClr val="213C31"/>
                 </a:solidFill>
@@ -5024,7 +5144,7 @@
               </a:defRPr>
             </a:pPr>
             <a:r>
-              <a:rPr sz="2025" b="0">
+              <a:rPr sz="2100" b="0">
                 <a:solidFill>
                   <a:srgbClr val="213C31"/>
                 </a:solidFill>
@@ -5042,7 +5162,7 @@
           <p:cNvPr id="9" name="">
             <a:extLst xmlns:a="http://schemas.openxmlformats.org/drawingml/2006/main">
               <a:ext uri="{FF2B5EF4-FFF2-40B4-BE49-F238E27FC236}">
-                <a16:creationId xmlns:a16="http://schemas.microsoft.com/office/drawing/2014/main" id="{EB1DBECB-5670-4E48-8674-0F836C91F29E}"/>
+                <a16:creationId xmlns:a16="http://schemas.microsoft.com/office/drawing/2014/main" id="{801CC231-41A8-4A01-A970-E9807AE8CADE}"/>
               </a:ext>
             </a:extLst>
           </p:cNvPr>
@@ -5053,8 +5173,8 @@
         </p:nvSpPr>
         <p:spPr>
           <a:xfrm xmlns:a="http://schemas.openxmlformats.org/drawingml/2006/main">
-            <a:off x="685800" y="4619625"/>
-            <a:ext cx="3524250" cy="809625"/>
+            <a:off x="685800" y="4781550"/>
+            <a:ext cx="3714750" cy="742950"/>
           </a:xfrm>
           <a:prstGeom xmlns:a="http://schemas.openxmlformats.org/drawingml/2006/main" prst="rect">
             <a:avLst/>
@@ -5067,8 +5187,8 @@
         <p:txBody>
           <a:bodyPr xmlns:a="http://schemas.openxmlformats.org/drawingml/2006/main"/>
           <a:lstStyle xmlns:a="http://schemas.openxmlformats.org/drawingml/2006/main">
-            <a:defPPr>
-              <a:defRPr sz="2025" b="1">
+            <a:defPPr algn="l">
+              <a:defRPr sz="2100" b="1">
                 <a:solidFill>
                   <a:srgbClr val="4D6A58"/>
                 </a:solidFill>
@@ -5079,8 +5199,9 @@
             </a:defPPr>
           </a:lstStyle>
           <a:p xmlns:a="http://schemas.openxmlformats.org/drawingml/2006/main">
-            <a:pPr>
-              <a:defRPr sz="2025" b="1">
+            <a:pPr algn="l">
+              <a:buNone/>
+              <a:defRPr sz="2100" b="1">
                 <a:solidFill>
                   <a:srgbClr val="4D6A58"/>
                 </a:solidFill>
@@ -5090,7 +5211,7 @@
               </a:defRPr>
             </a:pPr>
             <a:r>
-              <a:rPr sz="2025" b="1">
+              <a:rPr sz="2100" b="1">
                 <a:solidFill>
                   <a:srgbClr val="4D6A58"/>
                 </a:solidFill>
@@ -5108,7 +5229,7 @@
           <p:cNvPr id="10" name="">
             <a:extLst xmlns:a="http://schemas.openxmlformats.org/drawingml/2006/main">
               <a:ext uri="{FF2B5EF4-FFF2-40B4-BE49-F238E27FC236}">
-                <a16:creationId xmlns:a16="http://schemas.microsoft.com/office/drawing/2014/main" id="{F2EE6597-0C26-4131-B090-4CCC7DD566EB}"/>
+                <a16:creationId xmlns:a16="http://schemas.microsoft.com/office/drawing/2014/main" id="{05EFDEF3-8047-4F23-BC21-D3041D4B12E7}"/>
               </a:ext>
             </a:extLst>
           </p:cNvPr>
@@ -5119,8 +5240,8 @@
         </p:nvSpPr>
         <p:spPr>
           <a:xfrm xmlns:a="http://schemas.openxmlformats.org/drawingml/2006/main">
-            <a:off x="4667250" y="4619625"/>
-            <a:ext cx="6762750" cy="809625"/>
+            <a:off x="4953000" y="4781550"/>
+            <a:ext cx="6429375" cy="857250"/>
           </a:xfrm>
           <a:prstGeom xmlns:a="http://schemas.openxmlformats.org/drawingml/2006/main" prst="rect">
             <a:avLst/>
@@ -5133,8 +5254,8 @@
         <p:txBody>
           <a:bodyPr xmlns:a="http://schemas.openxmlformats.org/drawingml/2006/main"/>
           <a:lstStyle xmlns:a="http://schemas.openxmlformats.org/drawingml/2006/main">
-            <a:defPPr>
-              <a:defRPr sz="2025" b="0">
+            <a:defPPr algn="l">
+              <a:defRPr sz="2100" b="0">
                 <a:solidFill>
                   <a:srgbClr val="213C31"/>
                 </a:solidFill>
@@ -5145,8 +5266,9 @@
             </a:defPPr>
           </a:lstStyle>
           <a:p xmlns:a="http://schemas.openxmlformats.org/drawingml/2006/main">
-            <a:pPr>
-              <a:defRPr sz="2025" b="0">
+            <a:pPr algn="l">
+              <a:buNone/>
+              <a:defRPr sz="2100" b="0">
                 <a:solidFill>
                   <a:srgbClr val="213C31"/>
                 </a:solidFill>
@@ -5156,7 +5278,7 @@
               </a:defRPr>
             </a:pPr>
             <a:r>
-              <a:rPr sz="2025" b="0">
+              <a:rPr sz="2100" b="0">
                 <a:solidFill>
                   <a:srgbClr val="213C31"/>
                 </a:solidFill>
@@ -5172,7 +5294,7 @@
     </p:spTree>
     <p:extLst>
       <p:ext uri="{BB962C8B-B14F-4D97-AF65-F5344CB8AC3E}">
-        <p14:creationId xmlns:p14="http://schemas.microsoft.com/office/powerpoint/2010/main" val="911288522"/>
+        <p14:creationId xmlns:p14="http://schemas.microsoft.com/office/powerpoint/2010/main" val="1481459736"/>
       </p:ext>
     </p:extLst>
   </p:cSld>
@@ -5203,7 +5325,7 @@
           <p:cNvPr id="7" name="">
             <a:extLst xmlns:a="http://schemas.openxmlformats.org/drawingml/2006/main">
               <a:ext uri="{FF2B5EF4-FFF2-40B4-BE49-F238E27FC236}">
-                <a16:creationId xmlns:a16="http://schemas.microsoft.com/office/drawing/2014/main" id="{B1C60482-4DFE-4640-A359-1437D577C2F6}"/>
+                <a16:creationId xmlns:a16="http://schemas.microsoft.com/office/drawing/2014/main" id="{35376C75-BDB3-4F65-ABEC-4226165B8156}"/>
               </a:ext>
             </a:extLst>
           </p:cNvPr>
@@ -5228,8 +5350,8 @@
         <p:txBody>
           <a:bodyPr xmlns:a="http://schemas.openxmlformats.org/drawingml/2006/main"/>
           <a:lstStyle xmlns:a="http://schemas.openxmlformats.org/drawingml/2006/main">
-            <a:defPPr>
-              <a:defRPr sz="3225" b="1">
+            <a:defPPr algn="l">
+              <a:defRPr sz="3300" b="1">
                 <a:solidFill>
                   <a:srgbClr val="213C31"/>
                 </a:solidFill>
@@ -5240,8 +5362,9 @@
             </a:defPPr>
           </a:lstStyle>
           <a:p xmlns:a="http://schemas.openxmlformats.org/drawingml/2006/main">
-            <a:pPr>
-              <a:defRPr sz="3225" b="1">
+            <a:pPr algn="l">
+              <a:buNone/>
+              <a:defRPr sz="3300" b="1">
                 <a:solidFill>
                   <a:srgbClr val="213C31"/>
                 </a:solidFill>
@@ -5251,7 +5374,7 @@
               </a:defRPr>
             </a:pPr>
             <a:r>
-              <a:rPr sz="3225" b="1">
+              <a:rPr sz="3300" b="1">
                 <a:solidFill>
                   <a:srgbClr val="213C31"/>
                 </a:solidFill>
@@ -5269,7 +5392,7 @@
           <p:cNvPr id="2" name="">
             <a:extLst xmlns:a="http://schemas.openxmlformats.org/drawingml/2006/main">
               <a:ext uri="{FF2B5EF4-FFF2-40B4-BE49-F238E27FC236}">
-                <a16:creationId xmlns:a16="http://schemas.microsoft.com/office/drawing/2014/main" id="{2ED81443-2478-4E9A-A964-16AD4564AA97}"/>
+                <a16:creationId xmlns:a16="http://schemas.microsoft.com/office/drawing/2014/main" id="{B883D403-826F-49BC-84A8-B5E56EAC50E9}"/>
               </a:ext>
             </a:extLst>
           </p:cNvPr>
@@ -5307,6 +5430,7 @@
           </a:lstStyle>
           <a:p xmlns:a="http://schemas.openxmlformats.org/drawingml/2006/main">
             <a:pPr>
+              <a:buNone/>
               <a:defRPr sz="1350" b="0">
                 <a:solidFill>
                   <a:srgbClr val="55645B"/>
@@ -5335,7 +5459,7 @@
           <p:cNvPr id="3" name="">
             <a:extLst xmlns:a="http://schemas.openxmlformats.org/drawingml/2006/main">
               <a:ext uri="{FF2B5EF4-FFF2-40B4-BE49-F238E27FC236}">
-                <a16:creationId xmlns:a16="http://schemas.microsoft.com/office/drawing/2014/main" id="{0274F1F5-92F9-4605-85C0-4F0D7A1FB620}"/>
+                <a16:creationId xmlns:a16="http://schemas.microsoft.com/office/drawing/2014/main" id="{6DAC2E11-155A-4005-A324-403113DEEA06}"/>
               </a:ext>
             </a:extLst>
           </p:cNvPr>
@@ -5346,8 +5470,8 @@
         </p:nvSpPr>
         <p:spPr>
           <a:xfrm xmlns:a="http://schemas.openxmlformats.org/drawingml/2006/main">
-            <a:off x="685800" y="1762125"/>
-            <a:ext cx="10477500" cy="857250"/>
+            <a:off x="685800" y="1800225"/>
+            <a:ext cx="10382250" cy="523875"/>
           </a:xfrm>
           <a:prstGeom xmlns:a="http://schemas.openxmlformats.org/drawingml/2006/main" prst="rect">
             <a:avLst/>
@@ -5360,8 +5484,8 @@
         <p:txBody>
           <a:bodyPr xmlns:a="http://schemas.openxmlformats.org/drawingml/2006/main"/>
           <a:lstStyle xmlns:a="http://schemas.openxmlformats.org/drawingml/2006/main">
-            <a:defPPr>
-              <a:defRPr sz="2850" b="1">
+            <a:defPPr algn="l">
+              <a:defRPr sz="2400" b="1">
                 <a:solidFill>
                   <a:srgbClr val="4D6A58"/>
                 </a:solidFill>
@@ -5372,8 +5496,9 @@
             </a:defPPr>
           </a:lstStyle>
           <a:p xmlns:a="http://schemas.openxmlformats.org/drawingml/2006/main">
-            <a:pPr>
-              <a:defRPr sz="2850" b="1">
+            <a:pPr algn="l">
+              <a:buNone/>
+              <a:defRPr sz="2400" b="1">
                 <a:solidFill>
                   <a:srgbClr val="4D6A58"/>
                 </a:solidFill>
@@ -5383,7 +5508,7 @@
               </a:defRPr>
             </a:pPr>
             <a:r>
-              <a:rPr sz="2850" b="1">
+              <a:rPr sz="2400" b="1">
                 <a:solidFill>
                   <a:srgbClr val="4D6A58"/>
                 </a:solidFill>
@@ -5401,7 +5526,7 @@
           <p:cNvPr id="4" name="">
             <a:extLst xmlns:a="http://schemas.openxmlformats.org/drawingml/2006/main">
               <a:ext uri="{FF2B5EF4-FFF2-40B4-BE49-F238E27FC236}">
-                <a16:creationId xmlns:a16="http://schemas.microsoft.com/office/drawing/2014/main" id="{6CAB1015-FAF9-4BC7-87DA-1C55325BAEF7}"/>
+                <a16:creationId xmlns:a16="http://schemas.microsoft.com/office/drawing/2014/main" id="{421D99A8-E03E-46AE-ABA0-B7C20CCBE439}"/>
               </a:ext>
             </a:extLst>
           </p:cNvPr>
@@ -5412,8 +5537,8 @@
         </p:nvSpPr>
         <p:spPr>
           <a:xfrm xmlns:a="http://schemas.openxmlformats.org/drawingml/2006/main">
-            <a:off x="685800" y="2905125"/>
-            <a:ext cx="10477500" cy="1333500"/>
+            <a:off x="685800" y="2486025"/>
+            <a:ext cx="10382250" cy="1047750"/>
           </a:xfrm>
           <a:prstGeom xmlns:a="http://schemas.openxmlformats.org/drawingml/2006/main" prst="rect">
             <a:avLst/>
@@ -5426,8 +5551,8 @@
         <p:txBody>
           <a:bodyPr xmlns:a="http://schemas.openxmlformats.org/drawingml/2006/main"/>
           <a:lstStyle xmlns:a="http://schemas.openxmlformats.org/drawingml/2006/main">
-            <a:defPPr>
-              <a:defRPr sz="2100" b="0">
+            <a:defPPr algn="l">
+              <a:defRPr sz="2175" b="0">
                 <a:solidFill>
                   <a:srgbClr val="213C31"/>
                 </a:solidFill>
@@ -5438,8 +5563,9 @@
             </a:defPPr>
           </a:lstStyle>
           <a:p xmlns:a="http://schemas.openxmlformats.org/drawingml/2006/main">
-            <a:pPr>
-              <a:defRPr sz="2100" b="0">
+            <a:pPr algn="l">
+              <a:buNone/>
+              <a:defRPr sz="2175" b="0">
                 <a:solidFill>
                   <a:srgbClr val="213C31"/>
                 </a:solidFill>
@@ -5449,7 +5575,7 @@
               </a:defRPr>
             </a:pPr>
             <a:r>
-              <a:rPr sz="2100" b="0">
+              <a:rPr sz="2175" b="0">
                 <a:solidFill>
                   <a:srgbClr val="213C31"/>
                 </a:solidFill>
@@ -5461,8 +5587,9 @@
             </a:r>
           </a:p>
           <a:p xmlns:a="http://schemas.openxmlformats.org/drawingml/2006/main">
-            <a:pPr>
-              <a:defRPr sz="2100" b="0">
+            <a:pPr algn="l">
+              <a:buNone/>
+              <a:defRPr sz="2175" b="0">
                 <a:solidFill>
                   <a:srgbClr val="213C31"/>
                 </a:solidFill>
@@ -5472,7 +5599,7 @@
               </a:defRPr>
             </a:pPr>
             <a:r>
-              <a:rPr sz="2100" b="0">
+              <a:rPr sz="2175" b="0">
                 <a:solidFill>
                   <a:srgbClr val="213C31"/>
                 </a:solidFill>
@@ -5490,7 +5617,7 @@
           <p:cNvPr id="5" name="">
             <a:extLst xmlns:a="http://schemas.openxmlformats.org/drawingml/2006/main">
               <a:ext uri="{FF2B5EF4-FFF2-40B4-BE49-F238E27FC236}">
-                <a16:creationId xmlns:a16="http://schemas.microsoft.com/office/drawing/2014/main" id="{23109FF3-2A9C-4171-95A6-F97813696FB8}"/>
+                <a16:creationId xmlns:a16="http://schemas.microsoft.com/office/drawing/2014/main" id="{6E7C6544-B70D-40E5-8F9E-FF64000F278B}"/>
               </a:ext>
             </a:extLst>
           </p:cNvPr>
@@ -5501,8 +5628,8 @@
         </p:nvSpPr>
         <p:spPr>
           <a:xfrm xmlns:a="http://schemas.openxmlformats.org/drawingml/2006/main">
-            <a:off x="685800" y="4333875"/>
-            <a:ext cx="10477500" cy="523875"/>
+            <a:off x="685800" y="3933825"/>
+            <a:ext cx="10382250" cy="523875"/>
           </a:xfrm>
           <a:prstGeom xmlns:a="http://schemas.openxmlformats.org/drawingml/2006/main" prst="rect">
             <a:avLst/>
@@ -5515,8 +5642,8 @@
         <p:txBody>
           <a:bodyPr xmlns:a="http://schemas.openxmlformats.org/drawingml/2006/main"/>
           <a:lstStyle xmlns:a="http://schemas.openxmlformats.org/drawingml/2006/main">
-            <a:defPPr>
-              <a:defRPr sz="2325" b="1">
+            <a:defPPr algn="l">
+              <a:defRPr sz="2400" b="1">
                 <a:solidFill>
                   <a:srgbClr val="4D6A58"/>
                 </a:solidFill>
@@ -5527,8 +5654,9 @@
             </a:defPPr>
           </a:lstStyle>
           <a:p xmlns:a="http://schemas.openxmlformats.org/drawingml/2006/main">
-            <a:pPr>
-              <a:defRPr sz="2325" b="1">
+            <a:pPr algn="l">
+              <a:buNone/>
+              <a:defRPr sz="2400" b="1">
                 <a:solidFill>
                   <a:srgbClr val="4D6A58"/>
                 </a:solidFill>
@@ -5538,7 +5666,7 @@
               </a:defRPr>
             </a:pPr>
             <a:r>
-              <a:rPr sz="2325" b="1">
+              <a:rPr sz="2400" b="1">
                 <a:solidFill>
                   <a:srgbClr val="4D6A58"/>
                 </a:solidFill>
@@ -5556,7 +5684,7 @@
           <p:cNvPr id="6" name="">
             <a:extLst xmlns:a="http://schemas.openxmlformats.org/drawingml/2006/main">
               <a:ext uri="{FF2B5EF4-FFF2-40B4-BE49-F238E27FC236}">
-                <a16:creationId xmlns:a16="http://schemas.microsoft.com/office/drawing/2014/main" id="{4D02ABE5-A27F-4AF8-AB33-FEA6CC34EE51}"/>
+                <a16:creationId xmlns:a16="http://schemas.microsoft.com/office/drawing/2014/main" id="{22F4202D-850F-4971-9AEE-2CFB9B4BFAAA}"/>
               </a:ext>
             </a:extLst>
           </p:cNvPr>
@@ -5567,8 +5695,8 @@
         </p:nvSpPr>
         <p:spPr>
           <a:xfrm xmlns:a="http://schemas.openxmlformats.org/drawingml/2006/main">
-            <a:off x="685800" y="5010150"/>
-            <a:ext cx="10477500" cy="1190625"/>
+            <a:off x="685800" y="4619625"/>
+            <a:ext cx="10382250" cy="1428750"/>
           </a:xfrm>
           <a:prstGeom xmlns:a="http://schemas.openxmlformats.org/drawingml/2006/main" prst="rect">
             <a:avLst/>
@@ -5581,8 +5709,8 @@
         <p:txBody>
           <a:bodyPr xmlns:a="http://schemas.openxmlformats.org/drawingml/2006/main"/>
           <a:lstStyle xmlns:a="http://schemas.openxmlformats.org/drawingml/2006/main">
-            <a:defPPr>
-              <a:defRPr sz="2025" b="0">
+            <a:defPPr algn="l">
+              <a:defRPr sz="2175" b="0">
                 <a:solidFill>
                   <a:srgbClr val="213C31"/>
                 </a:solidFill>
@@ -5593,8 +5721,9 @@
             </a:defPPr>
           </a:lstStyle>
           <a:p xmlns:a="http://schemas.openxmlformats.org/drawingml/2006/main">
-            <a:pPr>
-              <a:defRPr sz="2025" b="0">
+            <a:pPr algn="l">
+              <a:buNone/>
+              <a:defRPr sz="2175" b="0">
                 <a:solidFill>
                   <a:srgbClr val="213C31"/>
                 </a:solidFill>
@@ -5604,7 +5733,7 @@
               </a:defRPr>
             </a:pPr>
             <a:r>
-              <a:rPr sz="2025" b="0">
+              <a:rPr sz="2175" b="0">
                 <a:solidFill>
                   <a:srgbClr val="213C31"/>
                 </a:solidFill>
@@ -5616,8 +5745,9 @@
             </a:r>
           </a:p>
           <a:p xmlns:a="http://schemas.openxmlformats.org/drawingml/2006/main">
-            <a:pPr>
-              <a:defRPr sz="2025" b="0">
+            <a:pPr algn="l">
+              <a:buNone/>
+              <a:defRPr sz="2175" b="0">
                 <a:solidFill>
                   <a:srgbClr val="213C31"/>
                 </a:solidFill>
@@ -5627,7 +5757,7 @@
               </a:defRPr>
             </a:pPr>
             <a:r>
-              <a:rPr sz="2025" b="0">
+              <a:rPr sz="2175" b="0">
                 <a:solidFill>
                   <a:srgbClr val="213C31"/>
                 </a:solidFill>
@@ -5639,8 +5769,9 @@
             </a:r>
           </a:p>
           <a:p xmlns:a="http://schemas.openxmlformats.org/drawingml/2006/main">
-            <a:pPr>
-              <a:defRPr sz="2025" b="0">
+            <a:pPr algn="l">
+              <a:buNone/>
+              <a:defRPr sz="2175" b="0">
                 <a:solidFill>
                   <a:srgbClr val="213C31"/>
                 </a:solidFill>
@@ -5650,7 +5781,7 @@
               </a:defRPr>
             </a:pPr>
             <a:r>
-              <a:rPr sz="2025" b="0">
+              <a:rPr sz="2175" b="0">
                 <a:solidFill>
                   <a:srgbClr val="213C31"/>
                 </a:solidFill>
@@ -5666,7 +5797,7 @@
     </p:spTree>
     <p:extLst>
       <p:ext uri="{BB962C8B-B14F-4D97-AF65-F5344CB8AC3E}">
-        <p14:creationId xmlns:p14="http://schemas.microsoft.com/office/powerpoint/2010/main" val="216352937"/>
+        <p14:creationId xmlns:p14="http://schemas.microsoft.com/office/powerpoint/2010/main" val="419965671"/>
       </p:ext>
     </p:extLst>
   </p:cSld>
@@ -5697,7 +5828,7 @@
           <p:cNvPr id="6" name="">
             <a:extLst xmlns:a="http://schemas.openxmlformats.org/drawingml/2006/main">
               <a:ext uri="{FF2B5EF4-FFF2-40B4-BE49-F238E27FC236}">
-                <a16:creationId xmlns:a16="http://schemas.microsoft.com/office/drawing/2014/main" id="{7C06705A-5038-4F7F-BAA6-28A1F97741DD}"/>
+                <a16:creationId xmlns:a16="http://schemas.microsoft.com/office/drawing/2014/main" id="{A0214B67-16FC-4E51-9596-68EAC90377AB}"/>
               </a:ext>
             </a:extLst>
           </p:cNvPr>
@@ -5722,8 +5853,8 @@
         <p:txBody>
           <a:bodyPr xmlns:a="http://schemas.openxmlformats.org/drawingml/2006/main"/>
           <a:lstStyle xmlns:a="http://schemas.openxmlformats.org/drawingml/2006/main">
-            <a:defPPr>
-              <a:defRPr sz="3225" b="1">
+            <a:defPPr algn="l">
+              <a:defRPr sz="3300" b="1">
                 <a:solidFill>
                   <a:srgbClr val="213C31"/>
                 </a:solidFill>
@@ -5734,8 +5865,9 @@
             </a:defPPr>
           </a:lstStyle>
           <a:p xmlns:a="http://schemas.openxmlformats.org/drawingml/2006/main">
-            <a:pPr>
-              <a:defRPr sz="3225" b="1">
+            <a:pPr algn="l">
+              <a:buNone/>
+              <a:defRPr sz="3300" b="1">
                 <a:solidFill>
                   <a:srgbClr val="213C31"/>
                 </a:solidFill>
@@ -5745,7 +5877,7 @@
               </a:defRPr>
             </a:pPr>
             <a:r>
-              <a:rPr sz="3225" b="1">
+              <a:rPr sz="3300" b="1">
                 <a:solidFill>
                   <a:srgbClr val="213C31"/>
                 </a:solidFill>
@@ -5763,7 +5895,7 @@
           <p:cNvPr id="2" name="">
             <a:extLst xmlns:a="http://schemas.openxmlformats.org/drawingml/2006/main">
               <a:ext uri="{FF2B5EF4-FFF2-40B4-BE49-F238E27FC236}">
-                <a16:creationId xmlns:a16="http://schemas.microsoft.com/office/drawing/2014/main" id="{56A31FA7-A925-4D09-8922-8FC9C6798471}"/>
+                <a16:creationId xmlns:a16="http://schemas.microsoft.com/office/drawing/2014/main" id="{86E65A5B-DCD0-4247-9A78-EF06005573FA}"/>
               </a:ext>
             </a:extLst>
           </p:cNvPr>
@@ -5801,6 +5933,7 @@
           </a:lstStyle>
           <a:p xmlns:a="http://schemas.openxmlformats.org/drawingml/2006/main">
             <a:pPr>
+              <a:buNone/>
               <a:defRPr sz="1350" b="0">
                 <a:solidFill>
                   <a:srgbClr val="55645B"/>
@@ -5829,7 +5962,7 @@
           <p:cNvPr id="3" name="">
             <a:extLst xmlns:a="http://schemas.openxmlformats.org/drawingml/2006/main">
               <a:ext uri="{FF2B5EF4-FFF2-40B4-BE49-F238E27FC236}">
-                <a16:creationId xmlns:a16="http://schemas.microsoft.com/office/drawing/2014/main" id="{D965C02C-F9E7-4699-B656-198884F34B52}"/>
+                <a16:creationId xmlns:a16="http://schemas.microsoft.com/office/drawing/2014/main" id="{F7FEB0A8-3D0D-4463-B356-FB7C4F820E1A}"/>
               </a:ext>
             </a:extLst>
           </p:cNvPr>
@@ -5840,8 +5973,8 @@
         </p:nvSpPr>
         <p:spPr>
           <a:xfrm xmlns:a="http://schemas.openxmlformats.org/drawingml/2006/main">
-            <a:off x="685800" y="1762125"/>
-            <a:ext cx="10477500" cy="1428750"/>
+            <a:off x="685800" y="1781175"/>
+            <a:ext cx="10382250" cy="1238250"/>
           </a:xfrm>
           <a:prstGeom xmlns:a="http://schemas.openxmlformats.org/drawingml/2006/main" prst="rect">
             <a:avLst/>
@@ -5854,8 +5987,8 @@
         <p:txBody>
           <a:bodyPr xmlns:a="http://schemas.openxmlformats.org/drawingml/2006/main"/>
           <a:lstStyle xmlns:a="http://schemas.openxmlformats.org/drawingml/2006/main">
-            <a:defPPr>
-              <a:defRPr sz="2850" b="1">
+            <a:defPPr algn="l">
+              <a:defRPr sz="3150" b="1">
                 <a:solidFill>
                   <a:srgbClr val="4D6A58"/>
                 </a:solidFill>
@@ -5866,8 +5999,9 @@
             </a:defPPr>
           </a:lstStyle>
           <a:p xmlns:a="http://schemas.openxmlformats.org/drawingml/2006/main">
-            <a:pPr>
-              <a:defRPr sz="2850" b="1">
+            <a:pPr algn="l">
+              <a:buNone/>
+              <a:defRPr sz="3150" b="1">
                 <a:solidFill>
                   <a:srgbClr val="4D6A58"/>
                 </a:solidFill>
@@ -5877,7 +6011,7 @@
               </a:defRPr>
             </a:pPr>
             <a:r>
-              <a:rPr sz="2850" b="1">
+              <a:rPr sz="3150" b="1">
                 <a:solidFill>
                   <a:srgbClr val="4D6A58"/>
                 </a:solidFill>
@@ -5889,8 +6023,9 @@
             </a:r>
           </a:p>
           <a:p xmlns:a="http://schemas.openxmlformats.org/drawingml/2006/main">
-            <a:pPr>
-              <a:defRPr sz="2850" b="1">
+            <a:pPr algn="l">
+              <a:buNone/>
+              <a:defRPr sz="3150" b="1">
                 <a:solidFill>
                   <a:srgbClr val="4D6A58"/>
                 </a:solidFill>
@@ -5900,7 +6035,7 @@
               </a:defRPr>
             </a:pPr>
             <a:r>
-              <a:rPr sz="2850" b="1">
+              <a:rPr sz="3150" b="1">
                 <a:solidFill>
                   <a:srgbClr val="4D6A58"/>
                 </a:solidFill>
@@ -5918,7 +6053,7 @@
           <p:cNvPr id="4" name="">
             <a:extLst xmlns:a="http://schemas.openxmlformats.org/drawingml/2006/main">
               <a:ext uri="{FF2B5EF4-FFF2-40B4-BE49-F238E27FC236}">
-                <a16:creationId xmlns:a16="http://schemas.microsoft.com/office/drawing/2014/main" id="{19D752FD-80B8-4FCD-B718-4DAF3169324C}"/>
+                <a16:creationId xmlns:a16="http://schemas.microsoft.com/office/drawing/2014/main" id="{0A743FD5-50B7-47E6-8B73-920686C7F003}"/>
               </a:ext>
             </a:extLst>
           </p:cNvPr>
@@ -5929,8 +6064,8 @@
         </p:nvSpPr>
         <p:spPr>
           <a:xfrm xmlns:a="http://schemas.openxmlformats.org/drawingml/2006/main">
-            <a:off x="685800" y="3524250"/>
-            <a:ext cx="10096500" cy="1285875"/>
+            <a:off x="685800" y="3533775"/>
+            <a:ext cx="10001250" cy="1095375"/>
           </a:xfrm>
           <a:prstGeom xmlns:a="http://schemas.openxmlformats.org/drawingml/2006/main" prst="rect">
             <a:avLst/>
@@ -5943,7 +6078,7 @@
         <p:txBody>
           <a:bodyPr xmlns:a="http://schemas.openxmlformats.org/drawingml/2006/main"/>
           <a:lstStyle xmlns:a="http://schemas.openxmlformats.org/drawingml/2006/main">
-            <a:defPPr>
+            <a:defPPr algn="l">
               <a:defRPr sz="2250" b="0">
                 <a:solidFill>
                   <a:srgbClr val="213C31"/>
@@ -5955,7 +6090,8 @@
             </a:defPPr>
           </a:lstStyle>
           <a:p xmlns:a="http://schemas.openxmlformats.org/drawingml/2006/main">
-            <a:pPr>
+            <a:pPr algn="l">
+              <a:buNone/>
               <a:defRPr sz="2250" b="0">
                 <a:solidFill>
                   <a:srgbClr val="213C31"/>
@@ -5984,7 +6120,7 @@
           <p:cNvPr id="5" name="">
             <a:extLst xmlns:a="http://schemas.openxmlformats.org/drawingml/2006/main">
               <a:ext uri="{FF2B5EF4-FFF2-40B4-BE49-F238E27FC236}">
-                <a16:creationId xmlns:a16="http://schemas.microsoft.com/office/drawing/2014/main" id="{D9B1D13D-DB1E-46C2-9C91-DD266687E3A7}"/>
+                <a16:creationId xmlns:a16="http://schemas.microsoft.com/office/drawing/2014/main" id="{8027B59D-2004-4767-AD56-231377541CA1}"/>
               </a:ext>
             </a:extLst>
           </p:cNvPr>
@@ -5995,8 +6131,8 @@
         </p:nvSpPr>
         <p:spPr>
           <a:xfrm xmlns:a="http://schemas.openxmlformats.org/drawingml/2006/main">
-            <a:off x="685800" y="5238750"/>
-            <a:ext cx="10096500" cy="1285875"/>
+            <a:off x="685800" y="5133975"/>
+            <a:ext cx="10001250" cy="904875"/>
           </a:xfrm>
           <a:prstGeom xmlns:a="http://schemas.openxmlformats.org/drawingml/2006/main" prst="rect">
             <a:avLst/>
@@ -6009,8 +6145,8 @@
         <p:txBody>
           <a:bodyPr xmlns:a="http://schemas.openxmlformats.org/drawingml/2006/main"/>
           <a:lstStyle xmlns:a="http://schemas.openxmlformats.org/drawingml/2006/main">
-            <a:defPPr>
-              <a:defRPr sz="2175" b="0">
+            <a:defPPr algn="l">
+              <a:defRPr sz="2250" b="0">
                 <a:solidFill>
                   <a:srgbClr val="55645B"/>
                 </a:solidFill>
@@ -6021,8 +6157,9 @@
             </a:defPPr>
           </a:lstStyle>
           <a:p xmlns:a="http://schemas.openxmlformats.org/drawingml/2006/main">
-            <a:pPr>
-              <a:defRPr sz="2175" b="0">
+            <a:pPr algn="l">
+              <a:buNone/>
+              <a:defRPr sz="2250" b="0">
                 <a:solidFill>
                   <a:srgbClr val="55645B"/>
                 </a:solidFill>
@@ -6032,7 +6169,7 @@
               </a:defRPr>
             </a:pPr>
             <a:r>
-              <a:rPr sz="2175" b="0">
+              <a:rPr sz="2250" b="0">
                 <a:solidFill>
                   <a:srgbClr val="55645B"/>
                 </a:solidFill>
@@ -6048,7 +6185,7 @@
     </p:spTree>
     <p:extLst>
       <p:ext uri="{BB962C8B-B14F-4D97-AF65-F5344CB8AC3E}">
-        <p14:creationId xmlns:p14="http://schemas.microsoft.com/office/powerpoint/2010/main" val="1308901864"/>
+        <p14:creationId xmlns:p14="http://schemas.microsoft.com/office/powerpoint/2010/main" val="1910864992"/>
       </p:ext>
     </p:extLst>
   </p:cSld>

</xml_diff>